<commit_message>
feat: schema 4.0 基线——Canonical Scene 唯一事实源、source gate 与双路线七案例证据
- 管线：freeze 前置冻结、事务化 ingest、ArrowSpec/BraceSpec/AssetSpec 确定性编译、视觉合同与修复计划
- 案例：新增 02-thinking-diffusion / 04-pareto-conditioned-diffusion 双路线案例，全部案例证据刷新至 schema 4.0.0
- 文档：README 中英文更新三主题 A/B 展示与当前 qa_failed 事实
- 验证：pytest 502 passed；ruff、compileall、cases --check、hygiene 全部通过
</commit_message>
<xml_diff>
--- a/examples/svg-seeded/02-thinking-diffusion/redraw.pptx
+++ b/examples/svg-seeded/02-thinking-diffusion/redraw.pptx
@@ -3090,7 +3090,7 @@
       <p:grpSpPr/>
       <p:sp>
         <p:nvSpPr>
-          <p:cNvPr id="2" name="af-svg-text-0001-text-01"/>
+          <p:cNvPr id="2" name="af-svg-text-0001-text-01" descr="{&quot;autofigure_element_id&quot;:&quot;svg-text-0001&quot;}"/>
           <p:cNvSpPr txBox="1"/>
           <p:nvPr/>
         </p:nvSpPr>
@@ -3107,7 +3107,7 @@
         </p:spPr>
         <p:txBody>
           <a:bodyPr wrap="none" anchor="t" lIns="0" rIns="0" tIns="0" bIns="0">
-            <a:spAutoFit/>
+            <a:noAutofit/>
           </a:bodyPr>
           <a:lstStyle/>
           <a:p>
@@ -3126,7 +3126,7 @@
       </p:sp>
       <p:sp>
         <p:nvSpPr>
-          <p:cNvPr id="3" name="af-svg-text-0002-text-01"/>
+          <p:cNvPr id="3" name="af-svg-text-0002-text-01" descr="{&quot;autofigure_element_id&quot;:&quot;svg-text-0002&quot;}"/>
           <p:cNvSpPr txBox="1"/>
           <p:nvPr/>
         </p:nvSpPr>
@@ -3143,7 +3143,7 @@
         </p:spPr>
         <p:txBody>
           <a:bodyPr wrap="none" anchor="t" lIns="0" rIns="0" tIns="0" bIns="0">
-            <a:spAutoFit/>
+            <a:noAutofit/>
           </a:bodyPr>
           <a:lstStyle/>
           <a:p>
@@ -3162,7 +3162,7 @@
       </p:sp>
       <p:sp>
         <p:nvSpPr>
-          <p:cNvPr id="4" name="af-svg-text-0003-text-01"/>
+          <p:cNvPr id="4" name="af-svg-text-0003-text-01" descr="{&quot;autofigure_element_id&quot;:&quot;svg-text-0003&quot;}"/>
           <p:cNvSpPr txBox="1"/>
           <p:nvPr/>
         </p:nvSpPr>
@@ -3179,7 +3179,7 @@
         </p:spPr>
         <p:txBody>
           <a:bodyPr wrap="none" anchor="t" lIns="0" rIns="0" tIns="0" bIns="0">
-            <a:spAutoFit/>
+            <a:noAutofit/>
           </a:bodyPr>
           <a:lstStyle/>
           <a:p>
@@ -3198,14 +3198,14 @@
       </p:sp>
       <p:sp>
         <p:nvSpPr>
-          <p:cNvPr id="5" name="af-svg-path-0001-freeform-01"/>
+          <p:cNvPr id="5" name="af-brace-top-left-image-freeform-01" descr="{&quot;autofigure_element_id&quot;:&quot;brace-top-left-image&quot;,&quot;brace_spec_sha256&quot;:&quot;5c93e3b88729a32268a364a04d02ea544effbb3a90c9ad6b48af75ff1cbef471&quot;,&quot;primitive_spec_sha256&quot;:&quot;5c93e3b88729a32268a364a04d02ea544effbb3a90c9ad6b48af75ff1cbef471&quot;}"/>
           <p:cNvSpPr/>
           <p:nvPr/>
         </p:nvSpPr>
         <p:spPr>
           <a:xfrm>
-            <a:off x="190500" y="333375"/>
-            <a:ext cx="1162050" cy="123825"/>
+            <a:off x="266700" y="381000"/>
+            <a:ext cx="1019175" cy="142875"/>
           </a:xfrm>
           <a:custGeom>
             <a:avLst/>
@@ -3214,57 +3214,73 @@
             <a:cxnLst/>
             <a:rect l="0" t="0" r="0" b="0"/>
             <a:pathLst>
-              <a:path w="1162050" h="123825">
+              <a:path w="1019175" h="142875">
                 <a:moveTo>
-                  <a:pt x="0" y="123825"/>
+                  <a:pt x="0" y="142875"/>
                 </a:moveTo>
+                <a:lnTo>
+                  <a:pt x="0" y="104775"/>
+                </a:lnTo>
                 <a:cubicBezTo>
-                  <a:pt x="0" y="57150"/>
-                  <a:pt x="19050" y="47625"/>
-                  <a:pt x="66675" y="47625"/>
+                  <a:pt x="0" y="79375"/>
+                  <a:pt x="19050" y="66675"/>
+                  <a:pt x="57150" y="66675"/>
                 </a:cubicBezTo>
                 <a:lnTo>
-                  <a:pt x="495300" y="47625"/>
+                  <a:pt x="461962" y="66675"/>
                 </a:lnTo>
                 <a:cubicBezTo>
-                  <a:pt x="508000" y="15875"/>
-                  <a:pt x="536575" y="0"/>
-                  <a:pt x="581025" y="0"/>
-                </a:cubicBezTo>
-                <a:cubicBezTo>
-                  <a:pt x="625475" y="0"/>
-                  <a:pt x="654050" y="15875"/>
-                  <a:pt x="666750" y="47625"/>
+                  <a:pt x="493712" y="66675"/>
+                  <a:pt x="509588" y="53975"/>
+                  <a:pt x="509588" y="28575"/>
                 </a:cubicBezTo>
                 <a:lnTo>
-                  <a:pt x="1095375" y="47625"/>
+                  <a:pt x="509588" y="0"/>
+                </a:lnTo>
+                <a:moveTo>
+                  <a:pt x="509588" y="0"/>
+                </a:moveTo>
+                <a:lnTo>
+                  <a:pt x="509588" y="28575"/>
                 </a:lnTo>
                 <a:cubicBezTo>
-                  <a:pt x="1143000" y="47625"/>
-                  <a:pt x="1162050" y="57150"/>
-                  <a:pt x="1162050" y="123825"/>
+                  <a:pt x="509588" y="53975"/>
+                  <a:pt x="525463" y="66675"/>
+                  <a:pt x="557212" y="66675"/>
                 </a:cubicBezTo>
+                <a:lnTo>
+                  <a:pt x="962025" y="66675"/>
+                </a:lnTo>
+                <a:cubicBezTo>
+                  <a:pt x="1000125" y="66675"/>
+                  <a:pt x="1019175" y="79375"/>
+                  <a:pt x="1019175" y="104775"/>
+                </a:cubicBezTo>
+                <a:lnTo>
+                  <a:pt x="1019175" y="142875"/>
+                </a:lnTo>
               </a:path>
             </a:pathLst>
           </a:custGeom>
           <a:noFill/>
-          <a:ln w="14288">
+          <a:ln w="9525" cap="rnd">
             <a:solidFill>
               <a:srgbClr val="333333"/>
             </a:solidFill>
-          </a:ln>
-        </p:spPr>
-      </p:sp>
-      <p:sp>
-        <p:nvSpPr>
-          <p:cNvPr id="6" name="af-svg-path-0002-freeform-01"/>
+            <a:miter/>
+          </a:ln>
+        </p:spPr>
+      </p:sp>
+      <p:sp>
+        <p:nvSpPr>
+          <p:cNvPr id="6" name="af-brace-top-left-prompt-freeform-01" descr="{&quot;autofigure_element_id&quot;:&quot;brace-top-left-prompt&quot;,&quot;brace_spec_sha256&quot;:&quot;49cda7351bbbdb0a01f8a7bedf77dcad130492a0bfffe0e6194fd3b5f41533fc&quot;,&quot;primitive_spec_sha256&quot;:&quot;49cda7351bbbdb0a01f8a7bedf77dcad130492a0bfffe0e6194fd3b5f41533fc&quot;}"/>
           <p:cNvSpPr/>
           <p:nvPr/>
         </p:nvSpPr>
         <p:spPr>
           <a:xfrm>
-            <a:off x="1533525" y="333375"/>
-            <a:ext cx="1181100" cy="123825"/>
+            <a:off x="1619250" y="381000"/>
+            <a:ext cx="1009650" cy="152400"/>
           </a:xfrm>
           <a:custGeom>
             <a:avLst/>
@@ -3273,57 +3289,73 @@
             <a:cxnLst/>
             <a:rect l="0" t="0" r="0" b="0"/>
             <a:pathLst>
-              <a:path w="1181100" h="123825">
+              <a:path w="1009650" h="152400">
                 <a:moveTo>
-                  <a:pt x="0" y="123825"/>
+                  <a:pt x="0" y="152400"/>
                 </a:moveTo>
+                <a:lnTo>
+                  <a:pt x="0" y="114300"/>
+                </a:lnTo>
                 <a:cubicBezTo>
-                  <a:pt x="0" y="57150"/>
-                  <a:pt x="19050" y="47625"/>
-                  <a:pt x="66675" y="47625"/>
+                  <a:pt x="0" y="82550"/>
+                  <a:pt x="19050" y="66675"/>
+                  <a:pt x="57150" y="66675"/>
                 </a:cubicBezTo>
                 <a:lnTo>
-                  <a:pt x="542925" y="47625"/>
+                  <a:pt x="457200" y="66675"/>
                 </a:lnTo>
                 <a:cubicBezTo>
-                  <a:pt x="555625" y="15875"/>
-                  <a:pt x="584200" y="0"/>
-                  <a:pt x="628650" y="0"/>
-                </a:cubicBezTo>
-                <a:cubicBezTo>
-                  <a:pt x="673100" y="0"/>
-                  <a:pt x="701675" y="15875"/>
-                  <a:pt x="714375" y="47625"/>
+                  <a:pt x="488950" y="66675"/>
+                  <a:pt x="504825" y="53975"/>
+                  <a:pt x="504825" y="28575"/>
                 </a:cubicBezTo>
                 <a:lnTo>
-                  <a:pt x="1114425" y="47625"/>
+                  <a:pt x="504825" y="0"/>
+                </a:lnTo>
+                <a:moveTo>
+                  <a:pt x="504825" y="0"/>
+                </a:moveTo>
+                <a:lnTo>
+                  <a:pt x="504825" y="28575"/>
                 </a:lnTo>
                 <a:cubicBezTo>
-                  <a:pt x="1162050" y="47625"/>
-                  <a:pt x="1181100" y="57150"/>
-                  <a:pt x="1181100" y="123825"/>
+                  <a:pt x="504825" y="53975"/>
+                  <a:pt x="520700" y="66675"/>
+                  <a:pt x="552450" y="66675"/>
                 </a:cubicBezTo>
+                <a:lnTo>
+                  <a:pt x="952500" y="66675"/>
+                </a:lnTo>
+                <a:cubicBezTo>
+                  <a:pt x="990600" y="66675"/>
+                  <a:pt x="1009650" y="82550"/>
+                  <a:pt x="1009650" y="114300"/>
+                </a:cubicBezTo>
+                <a:lnTo>
+                  <a:pt x="1009650" y="152400"/>
+                </a:lnTo>
               </a:path>
             </a:pathLst>
           </a:custGeom>
           <a:noFill/>
-          <a:ln w="14288">
+          <a:ln w="9525" cap="rnd">
             <a:solidFill>
               <a:srgbClr val="333333"/>
             </a:solidFill>
-          </a:ln>
-        </p:spPr>
-      </p:sp>
-      <p:sp>
-        <p:nvSpPr>
-          <p:cNvPr id="7" name="af-svg-path-0003-freeform-01"/>
+            <a:miter/>
+          </a:ln>
+        </p:spPr>
+      </p:sp>
+      <p:sp>
+        <p:nvSpPr>
+          <p:cNvPr id="7" name="af-brace-top-left-response-freeform-01" descr="{&quot;autofigure_element_id&quot;:&quot;brace-top-left-response&quot;,&quot;brace_spec_sha256&quot;:&quot;b0714461b1a73066d422722218b9833ec51149beab1aaed6297e227e14368e7e&quot;,&quot;primitive_spec_sha256&quot;:&quot;b0714461b1a73066d422722218b9833ec51149beab1aaed6297e227e14368e7e&quot;}"/>
           <p:cNvSpPr/>
           <p:nvPr/>
         </p:nvSpPr>
         <p:spPr>
           <a:xfrm>
-            <a:off x="2857500" y="333375"/>
-            <a:ext cx="3524250" cy="123825"/>
+            <a:off x="2962275" y="381000"/>
+            <a:ext cx="3352800" cy="152400"/>
           </a:xfrm>
           <a:custGeom>
             <a:avLst/>
@@ -3332,50 +3364,66 @@
             <a:cxnLst/>
             <a:rect l="0" t="0" r="0" b="0"/>
             <a:pathLst>
-              <a:path w="3524250" h="123825">
+              <a:path w="3352800" h="152400">
                 <a:moveTo>
-                  <a:pt x="0" y="123825"/>
+                  <a:pt x="0" y="152400"/>
                 </a:moveTo>
+                <a:lnTo>
+                  <a:pt x="0" y="114300"/>
+                </a:lnTo>
                 <a:cubicBezTo>
-                  <a:pt x="0" y="57150"/>
-                  <a:pt x="19050" y="47625"/>
-                  <a:pt x="66675" y="47625"/>
+                  <a:pt x="0" y="82550"/>
+                  <a:pt x="19050" y="66675"/>
+                  <a:pt x="57150" y="66675"/>
                 </a:cubicBezTo>
                 <a:lnTo>
-                  <a:pt x="1695450" y="47625"/>
+                  <a:pt x="1628775" y="66675"/>
                 </a:lnTo>
                 <a:cubicBezTo>
-                  <a:pt x="1708150" y="15875"/>
-                  <a:pt x="1736725" y="0"/>
-                  <a:pt x="1781175" y="0"/>
-                </a:cubicBezTo>
-                <a:cubicBezTo>
-                  <a:pt x="1825625" y="0"/>
-                  <a:pt x="1854200" y="15875"/>
-                  <a:pt x="1866900" y="47625"/>
+                  <a:pt x="1660525" y="66675"/>
+                  <a:pt x="1676400" y="53975"/>
+                  <a:pt x="1676400" y="28575"/>
                 </a:cubicBezTo>
                 <a:lnTo>
-                  <a:pt x="3457575" y="47625"/>
+                  <a:pt x="1676400" y="0"/>
+                </a:lnTo>
+                <a:moveTo>
+                  <a:pt x="1676400" y="0"/>
+                </a:moveTo>
+                <a:lnTo>
+                  <a:pt x="1676400" y="28575"/>
                 </a:lnTo>
                 <a:cubicBezTo>
-                  <a:pt x="3505200" y="47625"/>
-                  <a:pt x="3524250" y="57150"/>
-                  <a:pt x="3524250" y="123825"/>
+                  <a:pt x="1676400" y="53975"/>
+                  <a:pt x="1692275" y="66675"/>
+                  <a:pt x="1724025" y="66675"/>
                 </a:cubicBezTo>
+                <a:lnTo>
+                  <a:pt x="3295650" y="66675"/>
+                </a:lnTo>
+                <a:cubicBezTo>
+                  <a:pt x="3333750" y="66675"/>
+                  <a:pt x="3352800" y="82550"/>
+                  <a:pt x="3352800" y="114300"/>
+                </a:cubicBezTo>
+                <a:lnTo>
+                  <a:pt x="3352800" y="152400"/>
+                </a:lnTo>
               </a:path>
             </a:pathLst>
           </a:custGeom>
           <a:noFill/>
-          <a:ln w="14288">
+          <a:ln w="9525" cap="rnd">
             <a:solidFill>
               <a:srgbClr val="333333"/>
             </a:solidFill>
-          </a:ln>
-        </p:spPr>
-      </p:sp>
-      <p:sp>
-        <p:nvSpPr>
-          <p:cNvPr id="8" name="af-svg-rect-0001-rect-01"/>
+            <a:miter/>
+          </a:ln>
+        </p:spPr>
+      </p:sp>
+      <p:sp>
+        <p:nvSpPr>
+          <p:cNvPr id="8" name="af-svg-rect-0001-rect-01" descr="{&quot;autofigure_element_id&quot;:&quot;svg-rect-0001&quot;}"/>
           <p:cNvSpPr/>
           <p:nvPr/>
         </p:nvSpPr>
@@ -3396,6 +3444,7 @@
             <a:solidFill>
               <a:srgbClr val="E0D5B8"/>
             </a:solidFill>
+            <a:miter/>
           </a:ln>
           <a:effectLst/>
         </p:spPr>
@@ -3423,7 +3472,7 @@
       </p:sp>
       <p:sp>
         <p:nvSpPr>
-          <p:cNvPr id="9" name="af-svg-rect-0002-rect-01"/>
+          <p:cNvPr id="9" name="af-svg-rect-0002-rect-01" descr="{&quot;autofigure_element_id&quot;:&quot;svg-rect-0002&quot;}"/>
           <p:cNvSpPr/>
           <p:nvPr/>
         </p:nvSpPr>
@@ -3444,6 +3493,7 @@
             <a:solidFill>
               <a:srgbClr val="E0D5B8"/>
             </a:solidFill>
+            <a:miter/>
           </a:ln>
           <a:effectLst/>
         </p:spPr>
@@ -3471,7 +3521,7 @@
       </p:sp>
       <p:sp>
         <p:nvSpPr>
-          <p:cNvPr id="10" name="af-svg-rect-0003-rect-01"/>
+          <p:cNvPr id="10" name="af-svg-rect-0003-rect-01" descr="{&quot;autofigure_element_id&quot;:&quot;svg-rect-0003&quot;}"/>
           <p:cNvSpPr/>
           <p:nvPr/>
         </p:nvSpPr>
@@ -3492,6 +3542,7 @@
             <a:solidFill>
               <a:srgbClr val="E0D5B8"/>
             </a:solidFill>
+            <a:miter/>
           </a:ln>
           <a:effectLst/>
         </p:spPr>
@@ -3519,7 +3570,7 @@
       </p:sp>
       <p:sp>
         <p:nvSpPr>
-          <p:cNvPr id="11" name="af-svg-rect-0004-rect-01"/>
+          <p:cNvPr id="11" name="af-svg-rect-0004-rect-01" descr="{&quot;autofigure_element_id&quot;:&quot;svg-rect-0004&quot;}"/>
           <p:cNvSpPr/>
           <p:nvPr/>
         </p:nvSpPr>
@@ -3540,6 +3591,7 @@
             <a:solidFill>
               <a:srgbClr val="97C794"/>
             </a:solidFill>
+            <a:miter/>
           </a:ln>
           <a:effectLst/>
         </p:spPr>
@@ -3567,7 +3619,7 @@
       </p:sp>
       <p:sp>
         <p:nvSpPr>
-          <p:cNvPr id="12" name="af-svg-rect-0005-rect-01"/>
+          <p:cNvPr id="12" name="af-svg-rect-0005-rect-01" descr="{&quot;autofigure_element_id&quot;:&quot;svg-rect-0005&quot;}"/>
           <p:cNvSpPr/>
           <p:nvPr/>
         </p:nvSpPr>
@@ -3588,6 +3640,7 @@
             <a:solidFill>
               <a:srgbClr val="97C794"/>
             </a:solidFill>
+            <a:miter/>
           </a:ln>
           <a:effectLst/>
         </p:spPr>
@@ -3615,7 +3668,7 @@
       </p:sp>
       <p:sp>
         <p:nvSpPr>
-          <p:cNvPr id="13" name="af-svg-rect-0006-rect-01"/>
+          <p:cNvPr id="13" name="af-svg-rect-0006-rect-01" descr="{&quot;autofigure_element_id&quot;:&quot;svg-rect-0006&quot;}"/>
           <p:cNvSpPr/>
           <p:nvPr/>
         </p:nvSpPr>
@@ -3636,6 +3689,7 @@
             <a:solidFill>
               <a:srgbClr val="97C794"/>
             </a:solidFill>
+            <a:miter/>
           </a:ln>
           <a:effectLst/>
         </p:spPr>
@@ -3663,7 +3717,7 @@
       </p:sp>
       <p:sp>
         <p:nvSpPr>
-          <p:cNvPr id="14" name="af-svg-rect-0007-rect-01"/>
+          <p:cNvPr id="14" name="af-svg-rect-0007-rect-01" descr="{&quot;autofigure_element_id&quot;:&quot;svg-rect-0007&quot;}"/>
           <p:cNvSpPr/>
           <p:nvPr/>
         </p:nvSpPr>
@@ -3684,6 +3738,7 @@
             <a:solidFill>
               <a:srgbClr val="B3B3B3"/>
             </a:solidFill>
+            <a:miter/>
           </a:ln>
           <a:effectLst/>
         </p:spPr>
@@ -3711,7 +3766,7 @@
       </p:sp>
       <p:sp>
         <p:nvSpPr>
-          <p:cNvPr id="15" name="af-svg-rect-0008-rect-01"/>
+          <p:cNvPr id="15" name="af-svg-rect-0008-rect-01" descr="{&quot;autofigure_element_id&quot;:&quot;svg-rect-0008&quot;}"/>
           <p:cNvSpPr/>
           <p:nvPr/>
         </p:nvSpPr>
@@ -3732,6 +3787,7 @@
             <a:solidFill>
               <a:srgbClr val="B3B3B3"/>
             </a:solidFill>
+            <a:miter/>
           </a:ln>
           <a:effectLst/>
         </p:spPr>
@@ -3759,7 +3815,7 @@
       </p:sp>
       <p:sp>
         <p:nvSpPr>
-          <p:cNvPr id="16" name="af-svg-rect-0009-rect-01"/>
+          <p:cNvPr id="16" name="af-svg-rect-0009-rect-01" descr="{&quot;autofigure_element_id&quot;:&quot;svg-rect-0009&quot;}"/>
           <p:cNvSpPr/>
           <p:nvPr/>
         </p:nvSpPr>
@@ -3780,6 +3836,7 @@
             <a:solidFill>
               <a:srgbClr val="B3B3B3"/>
             </a:solidFill>
+            <a:miter/>
           </a:ln>
           <a:effectLst/>
         </p:spPr>
@@ -3807,7 +3864,7 @@
       </p:sp>
       <p:sp>
         <p:nvSpPr>
-          <p:cNvPr id="17" name="af-svg-rect-0010-rect-01"/>
+          <p:cNvPr id="17" name="af-svg-rect-0010-rect-01" descr="{&quot;autofigure_element_id&quot;:&quot;svg-rect-0010&quot;}"/>
           <p:cNvSpPr/>
           <p:nvPr/>
         </p:nvSpPr>
@@ -3828,6 +3885,7 @@
             <a:solidFill>
               <a:srgbClr val="B3B3B3"/>
             </a:solidFill>
+            <a:miter/>
           </a:ln>
           <a:effectLst/>
         </p:spPr>
@@ -3855,7 +3913,7 @@
       </p:sp>
       <p:sp>
         <p:nvSpPr>
-          <p:cNvPr id="18" name="af-svg-circle-0001-ellipse-01"/>
+          <p:cNvPr id="18" name="af-svg-circle-0001-ellipse-01" descr="{&quot;autofigure_element_id&quot;:&quot;svg-circle-0001&quot;}"/>
           <p:cNvSpPr/>
           <p:nvPr/>
         </p:nvSpPr>
@@ -3899,7 +3957,7 @@
       </p:sp>
       <p:sp>
         <p:nvSpPr>
-          <p:cNvPr id="19" name="af-svg-circle-0002-ellipse-01"/>
+          <p:cNvPr id="19" name="af-svg-circle-0002-ellipse-01" descr="{&quot;autofigure_element_id&quot;:&quot;svg-circle-0002&quot;}"/>
           <p:cNvSpPr/>
           <p:nvPr/>
         </p:nvSpPr>
@@ -3943,7 +4001,7 @@
       </p:sp>
       <p:sp>
         <p:nvSpPr>
-          <p:cNvPr id="20" name="af-svg-circle-0003-ellipse-01"/>
+          <p:cNvPr id="20" name="af-svg-circle-0003-ellipse-01" descr="{&quot;autofigure_element_id&quot;:&quot;svg-circle-0003&quot;}"/>
           <p:cNvSpPr/>
           <p:nvPr/>
         </p:nvSpPr>
@@ -3987,7 +4045,7 @@
       </p:sp>
       <p:sp>
         <p:nvSpPr>
-          <p:cNvPr id="21" name="af-svg-rect-0011-rect-01"/>
+          <p:cNvPr id="21" name="af-svg-rect-0011-rect-01" descr="{&quot;autofigure_element_id&quot;:&quot;svg-rect-0011&quot;}"/>
           <p:cNvSpPr/>
           <p:nvPr/>
         </p:nvSpPr>
@@ -4008,6 +4066,7 @@
             <a:solidFill>
               <a:srgbClr val="B3B3B3"/>
             </a:solidFill>
+            <a:miter/>
           </a:ln>
           <a:effectLst/>
         </p:spPr>
@@ -4035,7 +4094,7 @@
       </p:sp>
       <p:sp>
         <p:nvSpPr>
-          <p:cNvPr id="22" name="af-svg-rect-0012-rect-01"/>
+          <p:cNvPr id="22" name="af-svg-rect-0012-rect-01" descr="{&quot;autofigure_element_id&quot;:&quot;svg-rect-0012&quot;}"/>
           <p:cNvSpPr/>
           <p:nvPr/>
         </p:nvSpPr>
@@ -4056,6 +4115,7 @@
             <a:solidFill>
               <a:srgbClr val="B3B3B3"/>
             </a:solidFill>
+            <a:miter/>
           </a:ln>
           <a:effectLst/>
         </p:spPr>
@@ -4083,7 +4143,7 @@
       </p:sp>
       <p:sp>
         <p:nvSpPr>
-          <p:cNvPr id="23" name="af-svg-rect-0013-rect-01"/>
+          <p:cNvPr id="23" name="af-svg-rect-0013-rect-01" descr="{&quot;autofigure_element_id&quot;:&quot;svg-rect-0013&quot;}"/>
           <p:cNvSpPr/>
           <p:nvPr/>
         </p:nvSpPr>
@@ -4104,6 +4164,7 @@
             <a:solidFill>
               <a:srgbClr val="B3B3B3"/>
             </a:solidFill>
+            <a:miter/>
           </a:ln>
           <a:effectLst/>
         </p:spPr>
@@ -4131,7 +4192,7 @@
       </p:sp>
       <p:sp>
         <p:nvSpPr>
-          <p:cNvPr id="24" name="af-svg-rect-0014-rect-01"/>
+          <p:cNvPr id="24" name="af-svg-rect-0014-rect-01" descr="{&quot;autofigure_element_id&quot;:&quot;svg-rect-0014&quot;}"/>
           <p:cNvSpPr/>
           <p:nvPr/>
         </p:nvSpPr>
@@ -4152,6 +4213,7 @@
             <a:solidFill>
               <a:srgbClr val="B3B3B3"/>
             </a:solidFill>
+            <a:miter/>
           </a:ln>
           <a:effectLst/>
         </p:spPr>
@@ -4179,13 +4241,13 @@
       </p:sp>
       <p:cxnSp>
         <p:nvCxnSpPr>
-          <p:cNvPr id="25" name="af-svg-line-0001-connector-01"/>
+          <p:cNvPr id="25" name="af-arrow-left-input-to-model-connector-01" descr="{&quot;arrow_spec_sha256&quot;:&quot;3ffe9cdc8f5f061c55ce1ec952b712fedc2dde46c96ef5708f2194d5b2fc38a4&quot;,&quot;autofigure_element_id&quot;:&quot;arrow-left-input-to-model&quot;}"/>
           <p:cNvCxnSpPr/>
           <p:nvPr/>
         </p:nvCxnSpPr>
         <p:spPr>
           <a:xfrm>
-            <a:off x="4638675" y="904875"/>
+            <a:off x="4638675" y="885825"/>
             <a:ext cx="0" cy="219075"/>
           </a:xfrm>
           <a:prstGeom prst="line">
@@ -4193,8 +4255,9 @@
           </a:prstGeom>
           <a:ln w="19050">
             <a:solidFill>
-              <a:srgbClr val="333333"/>
+              <a:srgbClr val="000000"/>
             </a:solidFill>
+            <a:miter/>
             <a:tailEnd type="triangle" w="med" len="med"/>
           </a:ln>
           <a:effectLst/>
@@ -4216,7 +4279,7 @@
       </p:cxnSp>
       <p:sp>
         <p:nvSpPr>
-          <p:cNvPr id="26" name="af-svg-rect-0015-rect-01"/>
+          <p:cNvPr id="26" name="af-svg-rect-0015-rect-01" descr="{&quot;autofigure_element_id&quot;:&quot;svg-rect-0015&quot;}"/>
           <p:cNvSpPr/>
           <p:nvPr/>
         </p:nvSpPr>
@@ -4237,6 +4300,7 @@
             <a:solidFill>
               <a:srgbClr val="DCA3A3"/>
             </a:solidFill>
+            <a:miter/>
           </a:ln>
           <a:effectLst/>
         </p:spPr>
@@ -4264,7 +4328,7 @@
       </p:sp>
       <p:sp>
         <p:nvSpPr>
-          <p:cNvPr id="27" name="af-svg-text-0004-text-01"/>
+          <p:cNvPr id="27" name="af-svg-text-0004-text-01" descr="{&quot;autofigure_element_id&quot;:&quot;svg-text-0004&quot;}"/>
           <p:cNvSpPr txBox="1"/>
           <p:nvPr/>
         </p:nvSpPr>
@@ -4281,7 +4345,7 @@
         </p:spPr>
         <p:txBody>
           <a:bodyPr wrap="none" anchor="t" lIns="0" rIns="0" tIns="0" bIns="0">
-            <a:spAutoFit/>
+            <a:noAutofit/>
           </a:bodyPr>
           <a:lstStyle/>
           <a:p>
@@ -4300,22 +4364,23 @@
       </p:sp>
       <p:cxnSp>
         <p:nvCxnSpPr>
-          <p:cNvPr id="28" name="af-svg-line-0002-connector-01"/>
+          <p:cNvPr id="28" name="af-arrow-left-model-to-early-step-connector-01" descr="{&quot;arrow_spec_sha256&quot;:&quot;fda3382bea4aae9e54da4ff5ea82ccc618e7c9f617070db963bd908a872675ca&quot;,&quot;autofigure_element_id&quot;:&quot;arrow-left-model-to-early-step&quot;}"/>
           <p:cNvCxnSpPr/>
           <p:nvPr/>
         </p:nvCxnSpPr>
         <p:spPr>
           <a:xfrm>
-            <a:off x="4638675" y="1581150"/>
-            <a:ext cx="0" cy="323850"/>
+            <a:off x="4638675" y="1781175"/>
+            <a:ext cx="0" cy="466725"/>
           </a:xfrm>
           <a:prstGeom prst="line">
             <a:avLst/>
           </a:prstGeom>
           <a:ln w="19050">
             <a:solidFill>
-              <a:srgbClr val="333333"/>
+              <a:srgbClr val="000000"/>
             </a:solidFill>
+            <a:miter/>
             <a:tailEnd type="triangle" w="med" len="med"/>
           </a:ln>
           <a:effectLst/>
@@ -4337,7 +4402,7 @@
       </p:cxnSp>
       <p:sp>
         <p:nvSpPr>
-          <p:cNvPr id="29" name="af-svg-text-0005-text-01"/>
+          <p:cNvPr id="29" name="af-svg-text-0005-text-01" descr="{&quot;autofigure_element_id&quot;:&quot;svg-text-0005&quot;}"/>
           <p:cNvSpPr txBox="1"/>
           <p:nvPr/>
         </p:nvSpPr>
@@ -4354,7 +4419,7 @@
         </p:spPr>
         <p:txBody>
           <a:bodyPr wrap="none" anchor="t" lIns="0" rIns="0" tIns="0" bIns="0">
-            <a:spAutoFit/>
+            <a:noAutofit/>
           </a:bodyPr>
           <a:lstStyle/>
           <a:p>
@@ -4373,7 +4438,7 @@
       </p:sp>
       <p:sp>
         <p:nvSpPr>
-          <p:cNvPr id="30" name="af-svg-rect-0016-rect-01"/>
+          <p:cNvPr id="30" name="af-svg-rect-0016-rect-01" descr="{&quot;autofigure_element_id&quot;:&quot;svg-rect-0016&quot;}"/>
           <p:cNvSpPr/>
           <p:nvPr/>
         </p:nvSpPr>
@@ -4394,6 +4459,7 @@
             <a:solidFill>
               <a:srgbClr val="B3B3B3"/>
             </a:solidFill>
+            <a:miter/>
           </a:ln>
           <a:effectLst/>
         </p:spPr>
@@ -4421,7 +4487,7 @@
       </p:sp>
       <p:sp>
         <p:nvSpPr>
-          <p:cNvPr id="31" name="af-svg-rect-0017-rect-01"/>
+          <p:cNvPr id="31" name="af-svg-rect-0017-rect-01" descr="{&quot;autofigure_element_id&quot;:&quot;svg-rect-0017&quot;}"/>
           <p:cNvSpPr/>
           <p:nvPr/>
         </p:nvSpPr>
@@ -4442,6 +4508,7 @@
             <a:solidFill>
               <a:srgbClr val="B3B3B3"/>
             </a:solidFill>
+            <a:miter/>
           </a:ln>
           <a:effectLst/>
         </p:spPr>
@@ -4469,7 +4536,7 @@
       </p:sp>
       <p:sp>
         <p:nvSpPr>
-          <p:cNvPr id="32" name="af-svg-rect-0018-rect-01"/>
+          <p:cNvPr id="32" name="af-svg-rect-0018-rect-01" descr="{&quot;autofigure_element_id&quot;:&quot;svg-rect-0018&quot;}"/>
           <p:cNvSpPr/>
           <p:nvPr/>
         </p:nvSpPr>
@@ -4490,6 +4557,7 @@
             <a:solidFill>
               <a:srgbClr val="B3B3B3"/>
             </a:solidFill>
+            <a:miter/>
           </a:ln>
           <a:effectLst/>
         </p:spPr>
@@ -4517,7 +4585,7 @@
       </p:sp>
       <p:sp>
         <p:nvSpPr>
-          <p:cNvPr id="33" name="af-svg-rect-0019-rect-01"/>
+          <p:cNvPr id="33" name="af-svg-rect-0019-rect-01" descr="{&quot;autofigure_element_id&quot;:&quot;svg-rect-0019&quot;}"/>
           <p:cNvSpPr/>
           <p:nvPr/>
         </p:nvSpPr>
@@ -4538,6 +4606,7 @@
             <a:solidFill>
               <a:srgbClr val="B3B3B3"/>
             </a:solidFill>
+            <a:miter/>
           </a:ln>
           <a:effectLst/>
         </p:spPr>
@@ -4565,7 +4634,7 @@
       </p:sp>
       <p:sp>
         <p:nvSpPr>
-          <p:cNvPr id="34" name="af-svg-circle-0004-ellipse-01"/>
+          <p:cNvPr id="34" name="af-svg-circle-0004-ellipse-01" descr="{&quot;autofigure_element_id&quot;:&quot;svg-circle-0004&quot;}"/>
           <p:cNvSpPr/>
           <p:nvPr/>
         </p:nvSpPr>
@@ -4609,7 +4678,7 @@
       </p:sp>
       <p:sp>
         <p:nvSpPr>
-          <p:cNvPr id="35" name="af-svg-circle-0005-ellipse-01"/>
+          <p:cNvPr id="35" name="af-svg-circle-0005-ellipse-01" descr="{&quot;autofigure_element_id&quot;:&quot;svg-circle-0005&quot;}"/>
           <p:cNvSpPr/>
           <p:nvPr/>
         </p:nvSpPr>
@@ -4653,7 +4722,7 @@
       </p:sp>
       <p:sp>
         <p:nvSpPr>
-          <p:cNvPr id="36" name="af-svg-circle-0006-ellipse-01"/>
+          <p:cNvPr id="36" name="af-svg-circle-0006-ellipse-01" descr="{&quot;autofigure_element_id&quot;:&quot;svg-circle-0006&quot;}"/>
           <p:cNvSpPr/>
           <p:nvPr/>
         </p:nvSpPr>
@@ -4697,7 +4766,7 @@
       </p:sp>
       <p:sp>
         <p:nvSpPr>
-          <p:cNvPr id="37" name="af-svg-rect-0020-rect-01"/>
+          <p:cNvPr id="37" name="af-svg-rect-0020-rect-01" descr="{&quot;autofigure_element_id&quot;:&quot;svg-rect-0020&quot;}"/>
           <p:cNvSpPr/>
           <p:nvPr/>
         </p:nvSpPr>
@@ -4718,6 +4787,7 @@
             <a:solidFill>
               <a:srgbClr val="B3B3B3"/>
             </a:solidFill>
+            <a:miter/>
           </a:ln>
           <a:effectLst/>
         </p:spPr>
@@ -4745,7 +4815,7 @@
       </p:sp>
       <p:sp>
         <p:nvSpPr>
-          <p:cNvPr id="38" name="af-svg-rect-0021-rect-01"/>
+          <p:cNvPr id="38" name="af-svg-rect-0021-rect-01" descr="{&quot;autofigure_element_id&quot;:&quot;svg-rect-0021&quot;}"/>
           <p:cNvSpPr/>
           <p:nvPr/>
         </p:nvSpPr>
@@ -4766,6 +4836,7 @@
             <a:solidFill>
               <a:srgbClr val="9AB8E0"/>
             </a:solidFill>
+            <a:miter/>
           </a:ln>
           <a:effectLst/>
         </p:spPr>
@@ -4793,7 +4864,7 @@
       </p:sp>
       <p:sp>
         <p:nvSpPr>
-          <p:cNvPr id="39" name="af-svg-rect-0022-rect-01"/>
+          <p:cNvPr id="39" name="af-svg-rect-0022-rect-01" descr="{&quot;autofigure_element_id&quot;:&quot;svg-rect-0022&quot;}"/>
           <p:cNvSpPr/>
           <p:nvPr/>
         </p:nvSpPr>
@@ -4814,6 +4885,7 @@
             <a:solidFill>
               <a:srgbClr val="9AB8E0"/>
             </a:solidFill>
+            <a:miter/>
           </a:ln>
           <a:effectLst/>
         </p:spPr>
@@ -4841,7 +4913,7 @@
       </p:sp>
       <p:sp>
         <p:nvSpPr>
-          <p:cNvPr id="40" name="af-svg-rect-0023-rect-01"/>
+          <p:cNvPr id="40" name="af-svg-rect-0023-rect-01" descr="{&quot;autofigure_element_id&quot;:&quot;svg-rect-0023&quot;}"/>
           <p:cNvSpPr/>
           <p:nvPr/>
         </p:nvSpPr>
@@ -4862,6 +4934,7 @@
             <a:solidFill>
               <a:srgbClr val="9AB8E0"/>
             </a:solidFill>
+            <a:miter/>
           </a:ln>
           <a:effectLst/>
         </p:spPr>
@@ -4889,7 +4962,7 @@
       </p:sp>
       <p:sp>
         <p:nvSpPr>
-          <p:cNvPr id="41" name="af-svg-text-0006-text-01"/>
+          <p:cNvPr id="41" name="af-svg-text-0006-text-01" descr="{&quot;autofigure_element_id&quot;:&quot;svg-text-0006&quot;}"/>
           <p:cNvSpPr txBox="1"/>
           <p:nvPr/>
         </p:nvSpPr>
@@ -4906,7 +4979,7 @@
         </p:spPr>
         <p:txBody>
           <a:bodyPr wrap="none" anchor="t" lIns="0" rIns="0" tIns="0" bIns="0">
-            <a:spAutoFit/>
+            <a:noAutofit/>
           </a:bodyPr>
           <a:lstStyle/>
           <a:p>
@@ -4925,7 +4998,7 @@
       </p:sp>
       <p:sp>
         <p:nvSpPr>
-          <p:cNvPr id="42" name="af-svg-text-0007-text-01"/>
+          <p:cNvPr id="42" name="af-svg-text-0007-text-01" descr="{&quot;autofigure_element_id&quot;:&quot;svg-text-0007&quot;}"/>
           <p:cNvSpPr txBox="1"/>
           <p:nvPr/>
         </p:nvSpPr>
@@ -4942,7 +5015,7 @@
         </p:spPr>
         <p:txBody>
           <a:bodyPr wrap="none" anchor="t" lIns="0" rIns="0" tIns="0" bIns="0">
-            <a:spAutoFit/>
+            <a:noAutofit/>
           </a:bodyPr>
           <a:lstStyle/>
           <a:p>
@@ -4961,7 +5034,7 @@
       </p:sp>
       <p:sp>
         <p:nvSpPr>
-          <p:cNvPr id="43" name="af-svg-text-0008-text-01"/>
+          <p:cNvPr id="43" name="af-svg-text-0008-text-01" descr="{&quot;autofigure_element_id&quot;:&quot;svg-text-0008&quot;}"/>
           <p:cNvSpPr txBox="1"/>
           <p:nvPr/>
         </p:nvSpPr>
@@ -4978,7 +5051,7 @@
         </p:spPr>
         <p:txBody>
           <a:bodyPr wrap="none" anchor="t" lIns="0" rIns="0" tIns="0" bIns="0">
-            <a:spAutoFit/>
+            <a:noAutofit/>
           </a:bodyPr>
           <a:lstStyle/>
           <a:p>
@@ -4997,14 +5070,14 @@
       </p:sp>
       <p:sp>
         <p:nvSpPr>
-          <p:cNvPr id="44" name="af-svg-path-0004-freeform-01"/>
+          <p:cNvPr id="44" name="af-brace-left-early-answer-under-freeform-01" descr="{&quot;autofigure_element_id&quot;:&quot;brace-left-early-answer-under&quot;,&quot;brace_spec_sha256&quot;:&quot;bf904cdc1cc31f242d09a65ea9ee2d4c55db751f7d57527b4ac7a2b03c3cd4cd&quot;,&quot;primitive_spec_sha256&quot;:&quot;bf904cdc1cc31f242d09a65ea9ee2d4c55db751f7d57527b4ac7a2b03c3cd4cd&quot;}"/>
           <p:cNvSpPr/>
           <p:nvPr/>
         </p:nvSpPr>
         <p:spPr>
           <a:xfrm>
-            <a:off x="5286375" y="2733675"/>
-            <a:ext cx="1076325" cy="123825"/>
+            <a:off x="5324475" y="2771775"/>
+            <a:ext cx="1009650" cy="123825"/>
           </a:xfrm>
           <a:custGeom>
             <a:avLst/>
@@ -5013,57 +5086,73 @@
             <a:cxnLst/>
             <a:rect l="0" t="0" r="0" b="0"/>
             <a:pathLst>
-              <a:path w="1076325" h="123825">
+              <a:path w="1009650" h="123825">
                 <a:moveTo>
                   <a:pt x="0" y="0"/>
                 </a:moveTo>
+                <a:lnTo>
+                  <a:pt x="0" y="38100"/>
+                </a:lnTo>
                 <a:cubicBezTo>
-                  <a:pt x="0" y="66675"/>
-                  <a:pt x="19050" y="76200"/>
-                  <a:pt x="66675" y="76200"/>
+                  <a:pt x="0" y="57150"/>
+                  <a:pt x="19050" y="66675"/>
+                  <a:pt x="57150" y="66675"/>
                 </a:cubicBezTo>
                 <a:lnTo>
-                  <a:pt x="447675" y="76200"/>
+                  <a:pt x="457200" y="66675"/>
                 </a:lnTo>
                 <a:cubicBezTo>
-                  <a:pt x="460375" y="107950"/>
-                  <a:pt x="488950" y="123825"/>
-                  <a:pt x="533400" y="123825"/>
-                </a:cubicBezTo>
-                <a:cubicBezTo>
-                  <a:pt x="577850" y="123825"/>
-                  <a:pt x="606425" y="107950"/>
-                  <a:pt x="619125" y="76200"/>
+                  <a:pt x="488950" y="66675"/>
+                  <a:pt x="504825" y="76200"/>
+                  <a:pt x="504825" y="95250"/>
                 </a:cubicBezTo>
                 <a:lnTo>
-                  <a:pt x="1009650" y="76200"/>
+                  <a:pt x="504825" y="123825"/>
+                </a:lnTo>
+                <a:moveTo>
+                  <a:pt x="504825" y="123825"/>
+                </a:moveTo>
+                <a:lnTo>
+                  <a:pt x="504825" y="95250"/>
                 </a:lnTo>
                 <a:cubicBezTo>
-                  <a:pt x="1057275" y="76200"/>
-                  <a:pt x="1076325" y="66675"/>
-                  <a:pt x="1076325" y="0"/>
+                  <a:pt x="504825" y="76200"/>
+                  <a:pt x="520700" y="66675"/>
+                  <a:pt x="552450" y="66675"/>
                 </a:cubicBezTo>
+                <a:lnTo>
+                  <a:pt x="952500" y="66675"/>
+                </a:lnTo>
+                <a:cubicBezTo>
+                  <a:pt x="990600" y="66675"/>
+                  <a:pt x="1009650" y="57150"/>
+                  <a:pt x="1009650" y="38100"/>
+                </a:cubicBezTo>
+                <a:lnTo>
+                  <a:pt x="1009650" y="0"/>
+                </a:lnTo>
               </a:path>
             </a:pathLst>
           </a:custGeom>
           <a:noFill/>
-          <a:ln w="14288">
+          <a:ln w="9525" cap="rnd">
             <a:solidFill>
               <a:srgbClr val="333333"/>
             </a:solidFill>
-          </a:ln>
-        </p:spPr>
-      </p:sp>
-      <p:sp>
-        <p:nvSpPr>
-          <p:cNvPr id="45" name="af-svg-text-0009-text-01"/>
+            <a:miter/>
+          </a:ln>
+        </p:spPr>
+      </p:sp>
+      <p:sp>
+        <p:nvSpPr>
+          <p:cNvPr id="45" name="af-svg-text-0009-text-01" descr="{&quot;autofigure_element_id&quot;:&quot;svg-text-0009&quot;}"/>
           <p:cNvSpPr txBox="1"/>
           <p:nvPr/>
         </p:nvSpPr>
         <p:spPr>
           <a:xfrm rot="16200000">
-            <a:off x="6251305" y="2241947"/>
-            <a:ext cx="1060990" cy="392906"/>
+            <a:off x="6251305" y="2038350"/>
+            <a:ext cx="1060990" cy="800100"/>
           </a:xfrm>
           <a:prstGeom prst="rect">
             <a:avLst/>
@@ -5073,7 +5162,7 @@
         </p:spPr>
         <p:txBody>
           <a:bodyPr wrap="none" anchor="ctr" lIns="0" rIns="0" tIns="0" bIns="0">
-            <a:spAutoFit/>
+            <a:noAutofit/>
           </a:bodyPr>
           <a:lstStyle/>
           <a:p>
@@ -5092,14 +5181,14 @@
       </p:sp>
       <p:sp>
         <p:nvSpPr>
-          <p:cNvPr id="46" name="af-svg-path-0005-freeform-01"/>
+          <p:cNvPr id="46" name="af-brace-left-early-step-side-freeform-01" descr="{&quot;autofigure_element_id&quot;:&quot;brace-left-early-step-side&quot;,&quot;brace_spec_sha256&quot;:&quot;542ce5d3df54cbf1517ed5e11b999e68496cd61d7497d6a7553d8cb5626a5d68&quot;,&quot;primitive_spec_sha256&quot;:&quot;542ce5d3df54cbf1517ed5e11b999e68496cd61d7497d6a7553d8cb5626a5d68&quot;}"/>
           <p:cNvSpPr/>
           <p:nvPr/>
         </p:nvSpPr>
         <p:spPr>
           <a:xfrm>
             <a:off x="6496050" y="1952625"/>
-            <a:ext cx="123825" cy="733425"/>
+            <a:ext cx="142875" cy="723900"/>
           </a:xfrm>
           <a:custGeom>
             <a:avLst/>
@@ -5108,57 +5197,73 @@
             <a:cxnLst/>
             <a:rect l="0" t="0" r="0" b="0"/>
             <a:pathLst>
-              <a:path w="123825" h="733425">
+              <a:path w="142875" h="723900">
                 <a:moveTo>
                   <a:pt x="0" y="0"/>
                 </a:moveTo>
+                <a:lnTo>
+                  <a:pt x="38100" y="0"/>
+                </a:lnTo>
                 <a:cubicBezTo>
-                  <a:pt x="66675" y="0"/>
+                  <a:pt x="63500" y="0"/>
                   <a:pt x="76200" y="19050"/>
-                  <a:pt x="76200" y="66675"/>
+                  <a:pt x="76200" y="57150"/>
                 </a:cubicBezTo>
                 <a:lnTo>
-                  <a:pt x="76200" y="295275"/>
+                  <a:pt x="76200" y="314325"/>
                 </a:lnTo>
                 <a:cubicBezTo>
-                  <a:pt x="107950" y="307975"/>
-                  <a:pt x="123825" y="333375"/>
-                  <a:pt x="123825" y="371475"/>
+                  <a:pt x="76200" y="346075"/>
+                  <a:pt x="88900" y="361950"/>
+                  <a:pt x="114300" y="361950"/>
                 </a:cubicBezTo>
+                <a:lnTo>
+                  <a:pt x="142875" y="361950"/>
+                </a:lnTo>
+                <a:moveTo>
+                  <a:pt x="142875" y="361950"/>
+                </a:moveTo>
+                <a:lnTo>
+                  <a:pt x="114300" y="361950"/>
+                </a:lnTo>
                 <a:cubicBezTo>
-                  <a:pt x="123825" y="409575"/>
-                  <a:pt x="107950" y="434975"/>
-                  <a:pt x="76200" y="447675"/>
+                  <a:pt x="88900" y="361950"/>
+                  <a:pt x="76200" y="377825"/>
+                  <a:pt x="76200" y="409575"/>
                 </a:cubicBezTo>
                 <a:lnTo>
                   <a:pt x="76200" y="666750"/>
                 </a:lnTo>
                 <a:cubicBezTo>
-                  <a:pt x="76200" y="714375"/>
-                  <a:pt x="66675" y="733425"/>
-                  <a:pt x="0" y="733425"/>
+                  <a:pt x="76200" y="704850"/>
+                  <a:pt x="63500" y="723900"/>
+                  <a:pt x="38100" y="723900"/>
                 </a:cubicBezTo>
+                <a:lnTo>
+                  <a:pt x="0" y="723900"/>
+                </a:lnTo>
               </a:path>
             </a:pathLst>
           </a:custGeom>
           <a:noFill/>
-          <a:ln w="14288">
+          <a:ln w="9525" cap="rnd">
             <a:solidFill>
               <a:srgbClr val="333333"/>
             </a:solidFill>
-          </a:ln>
-        </p:spPr>
-      </p:sp>
-      <p:sp>
-        <p:nvSpPr>
-          <p:cNvPr id="47" name="af-svg-text-0010-text-01"/>
+            <a:miter/>
+          </a:ln>
+        </p:spPr>
+      </p:sp>
+      <p:sp>
+        <p:nvSpPr>
+          <p:cNvPr id="47" name="af-caption-left-early-line1-text-01" descr="{&quot;autofigure_element_id&quot;:&quot;caption-left-early-line1&quot;}"/>
           <p:cNvSpPr txBox="1"/>
           <p:nvPr/>
         </p:nvSpPr>
         <p:spPr>
           <a:xfrm>
-            <a:off x="4136136" y="2811780"/>
-            <a:ext cx="2014728" cy="476250"/>
+            <a:off x="4987004" y="2881074"/>
+            <a:ext cx="1694116" cy="422672"/>
           </a:xfrm>
           <a:prstGeom prst="rect">
             <a:avLst/>
@@ -5168,13 +5273,13 @@
         </p:spPr>
         <p:txBody>
           <a:bodyPr wrap="none" anchor="t" lIns="0" rIns="0" tIns="0" bIns="0">
-            <a:spAutoFit/>
+            <a:noAutofit/>
           </a:bodyPr>
           <a:lstStyle/>
           <a:p>
             <a:pPr algn="ctr"/>
             <a:r>
-              <a:rPr sz="1800" b="1">
+              <a:rPr sz="1462" b="1">
                 <a:solidFill>
                   <a:srgbClr val="F00000"/>
                 </a:solidFill>
@@ -5187,14 +5292,14 @@
       </p:sp>
       <p:sp>
         <p:nvSpPr>
-          <p:cNvPr id="48" name="af-svg-text-0011-text-01"/>
+          <p:cNvPr id="48" name="af-caption-left-early-line2-text-01" descr="{&quot;autofigure_element_id&quot;:&quot;caption-left-early-line2&quot;}"/>
           <p:cNvSpPr txBox="1"/>
           <p:nvPr/>
         </p:nvSpPr>
         <p:spPr>
           <a:xfrm>
-            <a:off x="4124706" y="3097530"/>
-            <a:ext cx="1980438" cy="476250"/>
+            <a:off x="5000935" y="3109674"/>
+            <a:ext cx="1666256" cy="422672"/>
           </a:xfrm>
           <a:prstGeom prst="rect">
             <a:avLst/>
@@ -5204,13 +5309,13 @@
         </p:spPr>
         <p:txBody>
           <a:bodyPr wrap="none" anchor="t" lIns="0" rIns="0" tIns="0" bIns="0">
-            <a:spAutoFit/>
+            <a:noAutofit/>
           </a:bodyPr>
           <a:lstStyle/>
           <a:p>
             <a:pPr algn="ctr"/>
             <a:r>
-              <a:rPr sz="1800" b="1">
+              <a:rPr sz="1462" b="1">
                 <a:solidFill>
                   <a:srgbClr val="F00000"/>
                 </a:solidFill>
@@ -5223,20 +5328,20 @@
       </p:sp>
       <p:sp>
         <p:nvSpPr>
-          <p:cNvPr id="49" name="af-svg-circle-0007-ellipse-01"/>
+          <p:cNvPr id="49" name="af-ellipsis-left-transition-dot-1-ellipse-01" descr="{&quot;autofigure_element_id&quot;:&quot;ellipsis-left-transition-dot-1&quot;}"/>
           <p:cNvSpPr/>
           <p:nvPr/>
         </p:nvSpPr>
         <p:spPr>
           <a:xfrm>
-            <a:off x="4608195" y="3122295"/>
-            <a:ext cx="41910" cy="41910"/>
+            <a:off x="4629150" y="3124200"/>
+            <a:ext cx="19050" cy="19050"/>
           </a:xfrm>
           <a:prstGeom prst="ellipse">
             <a:avLst/>
           </a:prstGeom>
           <a:solidFill>
-            <a:srgbClr val="666666"/>
+            <a:srgbClr val="000000"/>
           </a:solidFill>
           <a:ln>
             <a:noFill/>
@@ -5267,20 +5372,20 @@
       </p:sp>
       <p:sp>
         <p:nvSpPr>
-          <p:cNvPr id="50" name="af-svg-circle-0008-ellipse-01"/>
+          <p:cNvPr id="50" name="af-ellipsis-left-transition-dot-2-ellipse-01" descr="{&quot;autofigure_element_id&quot;:&quot;ellipsis-left-transition-dot-2&quot;}"/>
           <p:cNvSpPr/>
           <p:nvPr/>
         </p:nvSpPr>
         <p:spPr>
           <a:xfrm>
-            <a:off x="4608195" y="3217545"/>
-            <a:ext cx="41910" cy="41910"/>
+            <a:off x="4629150" y="3200400"/>
+            <a:ext cx="19050" cy="19050"/>
           </a:xfrm>
           <a:prstGeom prst="ellipse">
             <a:avLst/>
           </a:prstGeom>
           <a:solidFill>
-            <a:srgbClr val="666666"/>
+            <a:srgbClr val="000000"/>
           </a:solidFill>
           <a:ln>
             <a:noFill/>
@@ -5311,20 +5416,20 @@
       </p:sp>
       <p:sp>
         <p:nvSpPr>
-          <p:cNvPr id="51" name="af-svg-circle-0009-ellipse-01"/>
+          <p:cNvPr id="51" name="af-ellipsis-left-transition-dot-3-ellipse-01" descr="{&quot;autofigure_element_id&quot;:&quot;ellipsis-left-transition-dot-3&quot;}"/>
           <p:cNvSpPr/>
           <p:nvPr/>
         </p:nvSpPr>
         <p:spPr>
           <a:xfrm>
-            <a:off x="4608195" y="3312795"/>
-            <a:ext cx="41910" cy="41910"/>
+            <a:off x="4629150" y="3267075"/>
+            <a:ext cx="19050" cy="19050"/>
           </a:xfrm>
           <a:prstGeom prst="ellipse">
             <a:avLst/>
           </a:prstGeom>
           <a:solidFill>
-            <a:srgbClr val="666666"/>
+            <a:srgbClr val="000000"/>
           </a:solidFill>
           <a:ln>
             <a:noFill/>
@@ -5355,22 +5460,23 @@
       </p:sp>
       <p:cxnSp>
         <p:nvCxnSpPr>
-          <p:cNvPr id="52" name="af-svg-line-0003-connector-01"/>
+          <p:cNvPr id="52" name="af-arrow-left-to-later-step-connector-01" descr="{&quot;arrow_spec_sha256&quot;:&quot;814543cc03ba5312a69b42a86343b96829dbe9e87000d705708642bf3f9e55a1&quot;,&quot;autofigure_element_id&quot;:&quot;arrow-left-to-later-step&quot;}"/>
           <p:cNvCxnSpPr/>
           <p:nvPr/>
         </p:nvCxnSpPr>
         <p:spPr>
           <a:xfrm>
-            <a:off x="4638675" y="3448050"/>
-            <a:ext cx="0" cy="209550"/>
+            <a:off x="4638675" y="3429000"/>
+            <a:ext cx="0" cy="219075"/>
           </a:xfrm>
           <a:prstGeom prst="line">
             <a:avLst/>
           </a:prstGeom>
           <a:ln w="19050">
             <a:solidFill>
-              <a:srgbClr val="333333"/>
+              <a:srgbClr val="000000"/>
             </a:solidFill>
+            <a:miter/>
             <a:tailEnd type="triangle" w="med" len="med"/>
           </a:ln>
           <a:effectLst/>
@@ -5392,7 +5498,7 @@
       </p:cxnSp>
       <p:sp>
         <p:nvSpPr>
-          <p:cNvPr id="53" name="af-svg-rect-0024-rect-01"/>
+          <p:cNvPr id="53" name="af-svg-rect-0024-rect-01" descr="{&quot;autofigure_element_id&quot;:&quot;svg-rect-0024&quot;}"/>
           <p:cNvSpPr/>
           <p:nvPr/>
         </p:nvSpPr>
@@ -5413,6 +5519,7 @@
             <a:solidFill>
               <a:srgbClr val="1E7FB8"/>
             </a:solidFill>
+            <a:miter/>
           </a:ln>
           <a:effectLst/>
         </p:spPr>
@@ -5440,7 +5547,7 @@
       </p:sp>
       <p:sp>
         <p:nvSpPr>
-          <p:cNvPr id="54" name="af-svg-rect-0025-rect-01"/>
+          <p:cNvPr id="54" name="af-svg-rect-0025-rect-01" descr="{&quot;autofigure_element_id&quot;:&quot;svg-rect-0025&quot;}"/>
           <p:cNvSpPr/>
           <p:nvPr/>
         </p:nvSpPr>
@@ -5461,6 +5568,7 @@
             <a:solidFill>
               <a:srgbClr val="9AB8E0"/>
             </a:solidFill>
+            <a:miter/>
           </a:ln>
           <a:effectLst/>
         </p:spPr>
@@ -5488,7 +5596,7 @@
       </p:sp>
       <p:sp>
         <p:nvSpPr>
-          <p:cNvPr id="55" name="af-svg-rect-0026-rect-01"/>
+          <p:cNvPr id="55" name="af-svg-rect-0026-rect-01" descr="{&quot;autofigure_element_id&quot;:&quot;svg-rect-0026&quot;}"/>
           <p:cNvSpPr/>
           <p:nvPr/>
         </p:nvSpPr>
@@ -5509,6 +5617,7 @@
             <a:solidFill>
               <a:srgbClr val="B3B3B3"/>
             </a:solidFill>
+            <a:miter/>
           </a:ln>
           <a:effectLst/>
         </p:spPr>
@@ -5536,7 +5645,7 @@
       </p:sp>
       <p:sp>
         <p:nvSpPr>
-          <p:cNvPr id="56" name="af-svg-rect-0027-rect-01"/>
+          <p:cNvPr id="56" name="af-svg-rect-0027-rect-01" descr="{&quot;autofigure_element_id&quot;:&quot;svg-rect-0027&quot;}"/>
           <p:cNvSpPr/>
           <p:nvPr/>
         </p:nvSpPr>
@@ -5557,6 +5666,7 @@
             <a:solidFill>
               <a:srgbClr val="1E7FB8"/>
             </a:solidFill>
+            <a:miter/>
           </a:ln>
           <a:effectLst/>
         </p:spPr>
@@ -5584,20 +5694,20 @@
       </p:sp>
       <p:sp>
         <p:nvSpPr>
-          <p:cNvPr id="57" name="af-svg-circle-0010-ellipse-01"/>
+          <p:cNvPr id="57" name="af-ellipsis-left-later-row-dot-1-ellipse-01" descr="{&quot;autofigure_element_id&quot;:&quot;ellipsis-left-later-row-dot-1&quot;}"/>
           <p:cNvSpPr/>
           <p:nvPr/>
         </p:nvSpPr>
         <p:spPr>
           <a:xfrm>
-            <a:off x="4531995" y="3798570"/>
-            <a:ext cx="41910" cy="41910"/>
+            <a:off x="4555331" y="3807619"/>
+            <a:ext cx="23812" cy="23812"/>
           </a:xfrm>
           <a:prstGeom prst="ellipse">
             <a:avLst/>
           </a:prstGeom>
           <a:solidFill>
-            <a:srgbClr val="666666"/>
+            <a:srgbClr val="000000"/>
           </a:solidFill>
           <a:ln>
             <a:noFill/>
@@ -5628,20 +5738,20 @@
       </p:sp>
       <p:sp>
         <p:nvSpPr>
-          <p:cNvPr id="58" name="af-svg-circle-0011-ellipse-01"/>
+          <p:cNvPr id="58" name="af-ellipsis-left-later-row-dot-2-ellipse-01" descr="{&quot;autofigure_element_id&quot;:&quot;ellipsis-left-later-row-dot-2&quot;}"/>
           <p:cNvSpPr/>
           <p:nvPr/>
         </p:nvSpPr>
         <p:spPr>
           <a:xfrm>
-            <a:off x="4608195" y="3798570"/>
-            <a:ext cx="41910" cy="41910"/>
+            <a:off x="4622006" y="3807619"/>
+            <a:ext cx="23812" cy="23812"/>
           </a:xfrm>
           <a:prstGeom prst="ellipse">
             <a:avLst/>
           </a:prstGeom>
           <a:solidFill>
-            <a:srgbClr val="666666"/>
+            <a:srgbClr val="000000"/>
           </a:solidFill>
           <a:ln>
             <a:noFill/>
@@ -5672,20 +5782,20 @@
       </p:sp>
       <p:sp>
         <p:nvSpPr>
-          <p:cNvPr id="59" name="af-svg-circle-0012-ellipse-01"/>
+          <p:cNvPr id="59" name="af-ellipsis-left-later-row-dot-3-ellipse-01" descr="{&quot;autofigure_element_id&quot;:&quot;ellipsis-left-later-row-dot-3&quot;}"/>
           <p:cNvSpPr/>
           <p:nvPr/>
         </p:nvSpPr>
         <p:spPr>
           <a:xfrm>
-            <a:off x="4684395" y="3798570"/>
-            <a:ext cx="41910" cy="41910"/>
+            <a:off x="4688681" y="3807619"/>
+            <a:ext cx="23812" cy="23812"/>
           </a:xfrm>
           <a:prstGeom prst="ellipse">
             <a:avLst/>
           </a:prstGeom>
           <a:solidFill>
-            <a:srgbClr val="666666"/>
+            <a:srgbClr val="000000"/>
           </a:solidFill>
           <a:ln>
             <a:noFill/>
@@ -5716,7 +5826,7 @@
       </p:sp>
       <p:sp>
         <p:nvSpPr>
-          <p:cNvPr id="60" name="af-svg-rect-0028-rect-01"/>
+          <p:cNvPr id="60" name="af-svg-rect-0028-rect-01" descr="{&quot;autofigure_element_id&quot;:&quot;svg-rect-0028&quot;}"/>
           <p:cNvSpPr/>
           <p:nvPr/>
         </p:nvSpPr>
@@ -5737,6 +5847,7 @@
             <a:solidFill>
               <a:srgbClr val="B3B3B3"/>
             </a:solidFill>
+            <a:miter/>
           </a:ln>
           <a:effectLst/>
         </p:spPr>
@@ -5764,7 +5875,7 @@
       </p:sp>
       <p:sp>
         <p:nvSpPr>
-          <p:cNvPr id="61" name="af-svg-rect-0029-rect-01"/>
+          <p:cNvPr id="61" name="af-svg-rect-0029-rect-01" descr="{&quot;autofigure_element_id&quot;:&quot;svg-rect-0029&quot;}"/>
           <p:cNvSpPr/>
           <p:nvPr/>
         </p:nvSpPr>
@@ -5785,6 +5896,7 @@
             <a:solidFill>
               <a:srgbClr val="9AB8E0"/>
             </a:solidFill>
+            <a:miter/>
           </a:ln>
           <a:effectLst/>
         </p:spPr>
@@ -5812,7 +5924,7 @@
       </p:sp>
       <p:sp>
         <p:nvSpPr>
-          <p:cNvPr id="62" name="af-svg-rect-0030-rect-01"/>
+          <p:cNvPr id="62" name="af-svg-rect-0030-rect-01" descr="{&quot;autofigure_element_id&quot;:&quot;svg-rect-0030&quot;}"/>
           <p:cNvSpPr/>
           <p:nvPr/>
         </p:nvSpPr>
@@ -5833,6 +5945,7 @@
             <a:solidFill>
               <a:srgbClr val="9AB8E0"/>
             </a:solidFill>
+            <a:miter/>
           </a:ln>
           <a:effectLst/>
         </p:spPr>
@@ -5860,7 +5973,7 @@
       </p:sp>
       <p:sp>
         <p:nvSpPr>
-          <p:cNvPr id="63" name="af-svg-rect-0031-rect-01"/>
+          <p:cNvPr id="63" name="af-svg-rect-0031-rect-01" descr="{&quot;autofigure_element_id&quot;:&quot;svg-rect-0031&quot;}"/>
           <p:cNvSpPr/>
           <p:nvPr/>
         </p:nvSpPr>
@@ -5881,6 +5994,7 @@
             <a:solidFill>
               <a:srgbClr val="9AB8E0"/>
             </a:solidFill>
+            <a:miter/>
           </a:ln>
           <a:effectLst/>
         </p:spPr>
@@ -5908,7 +6022,7 @@
       </p:sp>
       <p:sp>
         <p:nvSpPr>
-          <p:cNvPr id="64" name="af-svg-text-0012-text-01"/>
+          <p:cNvPr id="64" name="af-svg-text-0012-text-01" descr="{&quot;autofigure_element_id&quot;:&quot;svg-text-0012&quot;}"/>
           <p:cNvSpPr txBox="1"/>
           <p:nvPr/>
         </p:nvSpPr>
@@ -5925,7 +6039,7 @@
         </p:spPr>
         <p:txBody>
           <a:bodyPr wrap="none" anchor="t" lIns="0" rIns="0" tIns="0" bIns="0">
-            <a:spAutoFit/>
+            <a:noAutofit/>
           </a:bodyPr>
           <a:lstStyle/>
           <a:p>
@@ -5944,7 +6058,7 @@
       </p:sp>
       <p:sp>
         <p:nvSpPr>
-          <p:cNvPr id="65" name="af-svg-text-0013-text-01"/>
+          <p:cNvPr id="65" name="af-svg-text-0013-text-01" descr="{&quot;autofigure_element_id&quot;:&quot;svg-text-0013&quot;}"/>
           <p:cNvSpPr txBox="1"/>
           <p:nvPr/>
         </p:nvSpPr>
@@ -5961,7 +6075,7 @@
         </p:spPr>
         <p:txBody>
           <a:bodyPr wrap="none" anchor="t" lIns="0" rIns="0" tIns="0" bIns="0">
-            <a:spAutoFit/>
+            <a:noAutofit/>
           </a:bodyPr>
           <a:lstStyle/>
           <a:p>
@@ -5980,7 +6094,7 @@
       </p:sp>
       <p:sp>
         <p:nvSpPr>
-          <p:cNvPr id="66" name="af-svg-text-0014-text-01"/>
+          <p:cNvPr id="66" name="af-svg-text-0014-text-01" descr="{&quot;autofigure_element_id&quot;:&quot;svg-text-0014&quot;}"/>
           <p:cNvSpPr txBox="1"/>
           <p:nvPr/>
         </p:nvSpPr>
@@ -5997,7 +6111,7 @@
         </p:spPr>
         <p:txBody>
           <a:bodyPr wrap="none" anchor="t" lIns="0" rIns="0" tIns="0" bIns="0">
-            <a:spAutoFit/>
+            <a:noAutofit/>
           </a:bodyPr>
           <a:lstStyle/>
           <a:p>
@@ -6016,7 +6130,7 @@
       </p:sp>
       <p:sp>
         <p:nvSpPr>
-          <p:cNvPr id="67" name="af-svg-text-0015-text-01"/>
+          <p:cNvPr id="67" name="af-svg-text-0015-text-01" descr="{&quot;autofigure_element_id&quot;:&quot;svg-text-0015&quot;}"/>
           <p:cNvSpPr txBox="1"/>
           <p:nvPr/>
         </p:nvSpPr>
@@ -6033,7 +6147,7 @@
         </p:spPr>
         <p:txBody>
           <a:bodyPr wrap="none" anchor="t" lIns="0" rIns="0" tIns="0" bIns="0">
-            <a:spAutoFit/>
+            <a:noAutofit/>
           </a:bodyPr>
           <a:lstStyle/>
           <a:p>
@@ -6052,7 +6166,7 @@
       </p:sp>
       <p:sp>
         <p:nvSpPr>
-          <p:cNvPr id="68" name="af-svg-text-0016-text-01"/>
+          <p:cNvPr id="68" name="af-svg-text-0016-text-01" descr="{&quot;autofigure_element_id&quot;:&quot;svg-text-0016&quot;}"/>
           <p:cNvSpPr txBox="1"/>
           <p:nvPr/>
         </p:nvSpPr>
@@ -6069,7 +6183,7 @@
         </p:spPr>
         <p:txBody>
           <a:bodyPr wrap="none" anchor="t" lIns="0" rIns="0" tIns="0" bIns="0">
-            <a:spAutoFit/>
+            <a:noAutofit/>
           </a:bodyPr>
           <a:lstStyle/>
           <a:p>
@@ -6088,7 +6202,7 @@
       </p:sp>
       <p:sp>
         <p:nvSpPr>
-          <p:cNvPr id="69" name="af-svg-text-0017-text-01"/>
+          <p:cNvPr id="69" name="af-svg-text-0017-text-01" descr="{&quot;autofigure_element_id&quot;:&quot;svg-text-0017&quot;}"/>
           <p:cNvSpPr txBox="1"/>
           <p:nvPr/>
         </p:nvSpPr>
@@ -6105,7 +6219,7 @@
         </p:spPr>
         <p:txBody>
           <a:bodyPr wrap="none" anchor="t" lIns="0" rIns="0" tIns="0" bIns="0">
-            <a:spAutoFit/>
+            <a:noAutofit/>
           </a:bodyPr>
           <a:lstStyle/>
           <a:p>
@@ -6124,14 +6238,14 @@
       </p:sp>
       <p:sp>
         <p:nvSpPr>
-          <p:cNvPr id="70" name="af-svg-path-0006-freeform-01"/>
+          <p:cNvPr id="70" name="af-brace-left-later-rationale-under-freeform-01" descr="{&quot;autofigure_element_id&quot;:&quot;brace-left-later-rationale-under&quot;,&quot;brace_spec_sha256&quot;:&quot;8d59cb0013aaa2f8e6894fb083ece3acbaad4abbb3bf9a947e2b7ab96578747e&quot;,&quot;primitive_spec_sha256&quot;:&quot;8d59cb0013aaa2f8e6894fb083ece3acbaad4abbb3bf9a947e2b7ab96578747e&quot;}"/>
           <p:cNvSpPr/>
           <p:nvPr/>
         </p:nvSpPr>
         <p:spPr>
           <a:xfrm>
-            <a:off x="2905125" y="4238625"/>
-            <a:ext cx="1524000" cy="123825"/>
+            <a:off x="3228975" y="4257675"/>
+            <a:ext cx="1009650" cy="123825"/>
           </a:xfrm>
           <a:custGeom>
             <a:avLst/>
@@ -6140,57 +6254,73 @@
             <a:cxnLst/>
             <a:rect l="0" t="0" r="0" b="0"/>
             <a:pathLst>
-              <a:path w="1524000" h="123825">
+              <a:path w="1009650" h="123825">
                 <a:moveTo>
                   <a:pt x="0" y="0"/>
                 </a:moveTo>
+                <a:lnTo>
+                  <a:pt x="0" y="38100"/>
+                </a:lnTo>
                 <a:cubicBezTo>
-                  <a:pt x="0" y="66675"/>
-                  <a:pt x="19050" y="76200"/>
-                  <a:pt x="66675" y="76200"/>
+                  <a:pt x="0" y="57150"/>
+                  <a:pt x="19050" y="66675"/>
+                  <a:pt x="57150" y="66675"/>
                 </a:cubicBezTo>
                 <a:lnTo>
-                  <a:pt x="676275" y="76200"/>
+                  <a:pt x="457200" y="66675"/>
                 </a:lnTo>
                 <a:cubicBezTo>
-                  <a:pt x="688975" y="107950"/>
-                  <a:pt x="717550" y="123825"/>
-                  <a:pt x="762000" y="123825"/>
-                </a:cubicBezTo>
-                <a:cubicBezTo>
-                  <a:pt x="806450" y="123825"/>
-                  <a:pt x="835025" y="107950"/>
-                  <a:pt x="847725" y="76200"/>
+                  <a:pt x="488950" y="66675"/>
+                  <a:pt x="504825" y="76200"/>
+                  <a:pt x="504825" y="95250"/>
                 </a:cubicBezTo>
                 <a:lnTo>
-                  <a:pt x="1457325" y="76200"/>
+                  <a:pt x="504825" y="123825"/>
+                </a:lnTo>
+                <a:moveTo>
+                  <a:pt x="504825" y="123825"/>
+                </a:moveTo>
+                <a:lnTo>
+                  <a:pt x="504825" y="95250"/>
                 </a:lnTo>
                 <a:cubicBezTo>
-                  <a:pt x="1504950" y="76200"/>
-                  <a:pt x="1524000" y="66675"/>
-                  <a:pt x="1524000" y="0"/>
+                  <a:pt x="504825" y="76200"/>
+                  <a:pt x="520700" y="66675"/>
+                  <a:pt x="552450" y="66675"/>
                 </a:cubicBezTo>
+                <a:lnTo>
+                  <a:pt x="952500" y="66675"/>
+                </a:lnTo>
+                <a:cubicBezTo>
+                  <a:pt x="990600" y="66675"/>
+                  <a:pt x="1009650" y="57150"/>
+                  <a:pt x="1009650" y="38100"/>
+                </a:cubicBezTo>
+                <a:lnTo>
+                  <a:pt x="1009650" y="0"/>
+                </a:lnTo>
               </a:path>
             </a:pathLst>
           </a:custGeom>
           <a:noFill/>
-          <a:ln w="14288">
+          <a:ln w="9525" cap="rnd">
             <a:solidFill>
               <a:srgbClr val="333333"/>
             </a:solidFill>
-          </a:ln>
-        </p:spPr>
-      </p:sp>
-      <p:sp>
-        <p:nvSpPr>
-          <p:cNvPr id="71" name="af-svg-text-0018-text-01"/>
+            <a:miter/>
+          </a:ln>
+        </p:spPr>
+      </p:sp>
+      <p:sp>
+        <p:nvSpPr>
+          <p:cNvPr id="71" name="af-svg-text-0018-text-01" descr="{&quot;autofigure_element_id&quot;:&quot;svg-text-0018&quot;}"/>
           <p:cNvSpPr txBox="1"/>
           <p:nvPr/>
         </p:nvSpPr>
         <p:spPr>
           <a:xfrm rot="16200000">
-            <a:off x="6247257" y="3746897"/>
-            <a:ext cx="1069086" cy="392906"/>
+            <a:off x="6247257" y="3543300"/>
+            <a:ext cx="1069086" cy="800100"/>
           </a:xfrm>
           <a:prstGeom prst="rect">
             <a:avLst/>
@@ -6200,7 +6330,7 @@
         </p:spPr>
         <p:txBody>
           <a:bodyPr wrap="none" anchor="ctr" lIns="0" rIns="0" tIns="0" bIns="0">
-            <a:spAutoFit/>
+            <a:noAutofit/>
           </a:bodyPr>
           <a:lstStyle/>
           <a:p>
@@ -6219,14 +6349,14 @@
       </p:sp>
       <p:sp>
         <p:nvSpPr>
-          <p:cNvPr id="72" name="af-svg-path-0007-freeform-01"/>
+          <p:cNvPr id="72" name="af-brace-left-later-step-side-freeform-01" descr="{&quot;autofigure_element_id&quot;:&quot;brace-left-later-step-side&quot;,&quot;brace_spec_sha256&quot;:&quot;de0952819aefecdd272f0f4fc3751a530c60c180d99cf15db867b57e226f63ec&quot;,&quot;primitive_spec_sha256&quot;:&quot;de0952819aefecdd272f0f4fc3751a530c60c180d99cf15db867b57e226f63ec&quot;}"/>
           <p:cNvSpPr/>
           <p:nvPr/>
         </p:nvSpPr>
         <p:spPr>
           <a:xfrm>
             <a:off x="6496050" y="3457575"/>
-            <a:ext cx="123825" cy="733425"/>
+            <a:ext cx="142875" cy="723900"/>
           </a:xfrm>
           <a:custGeom>
             <a:avLst/>
@@ -6235,57 +6365,73 @@
             <a:cxnLst/>
             <a:rect l="0" t="0" r="0" b="0"/>
             <a:pathLst>
-              <a:path w="123825" h="733425">
+              <a:path w="142875" h="723900">
                 <a:moveTo>
                   <a:pt x="0" y="0"/>
                 </a:moveTo>
+                <a:lnTo>
+                  <a:pt x="38100" y="0"/>
+                </a:lnTo>
                 <a:cubicBezTo>
-                  <a:pt x="66675" y="0"/>
+                  <a:pt x="63500" y="0"/>
                   <a:pt x="76200" y="19050"/>
-                  <a:pt x="76200" y="66675"/>
+                  <a:pt x="76200" y="57150"/>
                 </a:cubicBezTo>
                 <a:lnTo>
-                  <a:pt x="76200" y="295275"/>
+                  <a:pt x="76200" y="314325"/>
                 </a:lnTo>
                 <a:cubicBezTo>
-                  <a:pt x="107950" y="307975"/>
-                  <a:pt x="123825" y="333375"/>
-                  <a:pt x="123825" y="371475"/>
+                  <a:pt x="76200" y="346075"/>
+                  <a:pt x="88900" y="361950"/>
+                  <a:pt x="114300" y="361950"/>
                 </a:cubicBezTo>
+                <a:lnTo>
+                  <a:pt x="142875" y="361950"/>
+                </a:lnTo>
+                <a:moveTo>
+                  <a:pt x="142875" y="361950"/>
+                </a:moveTo>
+                <a:lnTo>
+                  <a:pt x="114300" y="361950"/>
+                </a:lnTo>
                 <a:cubicBezTo>
-                  <a:pt x="123825" y="409575"/>
-                  <a:pt x="107950" y="434975"/>
-                  <a:pt x="76200" y="447675"/>
+                  <a:pt x="88900" y="361950"/>
+                  <a:pt x="76200" y="377825"/>
+                  <a:pt x="76200" y="409575"/>
                 </a:cubicBezTo>
                 <a:lnTo>
                   <a:pt x="76200" y="666750"/>
                 </a:lnTo>
                 <a:cubicBezTo>
-                  <a:pt x="76200" y="714375"/>
-                  <a:pt x="66675" y="733425"/>
-                  <a:pt x="0" y="733425"/>
+                  <a:pt x="76200" y="704850"/>
+                  <a:pt x="63500" y="723900"/>
+                  <a:pt x="38100" y="723900"/>
                 </a:cubicBezTo>
+                <a:lnTo>
+                  <a:pt x="0" y="723900"/>
+                </a:lnTo>
               </a:path>
             </a:pathLst>
           </a:custGeom>
           <a:noFill/>
-          <a:ln w="14288">
+          <a:ln w="9525" cap="rnd">
             <a:solidFill>
               <a:srgbClr val="333333"/>
             </a:solidFill>
-          </a:ln>
-        </p:spPr>
-      </p:sp>
-      <p:sp>
-        <p:nvSpPr>
-          <p:cNvPr id="73" name="af-svg-text-0019-text-01"/>
+            <a:miter/>
+          </a:ln>
+        </p:spPr>
+      </p:sp>
+      <p:sp>
+        <p:nvSpPr>
+          <p:cNvPr id="73" name="af-caption-left-later-line1-text-01" descr="{&quot;autofigure_element_id&quot;:&quot;caption-left-later-line1&quot;}"/>
           <p:cNvSpPr txBox="1"/>
           <p:nvPr/>
         </p:nvSpPr>
         <p:spPr>
           <a:xfrm>
-            <a:off x="1894713" y="4240530"/>
-            <a:ext cx="2154174" cy="476250"/>
+            <a:off x="2830092" y="4319349"/>
+            <a:ext cx="1807416" cy="422672"/>
           </a:xfrm>
           <a:prstGeom prst="rect">
             <a:avLst/>
@@ -6295,13 +6441,13 @@
         </p:spPr>
         <p:txBody>
           <a:bodyPr wrap="none" anchor="t" lIns="0" rIns="0" tIns="0" bIns="0">
-            <a:spAutoFit/>
+            <a:noAutofit/>
           </a:bodyPr>
           <a:lstStyle/>
           <a:p>
             <a:pPr algn="ctr"/>
             <a:r>
-              <a:rPr sz="1800" b="1">
+              <a:rPr sz="1462" b="1">
                 <a:solidFill>
                   <a:srgbClr val="F00000"/>
                 </a:solidFill>
@@ -6314,14 +6460,14 @@
       </p:sp>
       <p:sp>
         <p:nvSpPr>
-          <p:cNvPr id="74" name="af-svg-text-0020-text-01"/>
+          <p:cNvPr id="74" name="af-caption-left-later-line2-text-01" descr="{&quot;autofigure_element_id&quot;:&quot;caption-left-later-line2&quot;}"/>
           <p:cNvSpPr txBox="1"/>
           <p:nvPr/>
         </p:nvSpPr>
         <p:spPr>
           <a:xfrm>
-            <a:off x="2059305" y="4526280"/>
-            <a:ext cx="1882140" cy="476250"/>
+            <a:off x="2940606" y="4547949"/>
+            <a:ext cx="1586389" cy="422672"/>
           </a:xfrm>
           <a:prstGeom prst="rect">
             <a:avLst/>
@@ -6331,13 +6477,13 @@
         </p:spPr>
         <p:txBody>
           <a:bodyPr wrap="none" anchor="t" lIns="0" rIns="0" tIns="0" bIns="0">
-            <a:spAutoFit/>
+            <a:noAutofit/>
           </a:bodyPr>
           <a:lstStyle/>
           <a:p>
             <a:pPr algn="ctr"/>
             <a:r>
-              <a:rPr sz="1800" b="1">
+              <a:rPr sz="1462" b="1">
                 <a:solidFill>
                   <a:srgbClr val="F00000"/>
                 </a:solidFill>
@@ -6350,7 +6496,7 @@
       </p:sp>
       <p:sp>
         <p:nvSpPr>
-          <p:cNvPr id="75" name="af-svg-rect-0032-rect-01"/>
+          <p:cNvPr id="75" name="af-svg-rect-0032-rect-01" descr="{&quot;autofigure_element_id&quot;:&quot;svg-rect-0032&quot;}"/>
           <p:cNvSpPr/>
           <p:nvPr/>
         </p:nvSpPr>
@@ -6371,6 +6517,7 @@
             <a:solidFill>
               <a:srgbClr val="808080"/>
             </a:solidFill>
+            <a:miter/>
           </a:ln>
           <a:effectLst/>
         </p:spPr>
@@ -6398,7 +6545,7 @@
       </p:sp>
       <p:sp>
         <p:nvSpPr>
-          <p:cNvPr id="76" name="af-svg-rect-0033-rect-01"/>
+          <p:cNvPr id="76" name="af-svg-rect-0033-rect-01" descr="{&quot;autofigure_element_id&quot;:&quot;svg-rect-0033&quot;}"/>
           <p:cNvSpPr/>
           <p:nvPr/>
         </p:nvSpPr>
@@ -6419,6 +6566,7 @@
             <a:solidFill>
               <a:srgbClr val="B3B3B3"/>
             </a:solidFill>
+            <a:miter/>
           </a:ln>
           <a:effectLst/>
         </p:spPr>
@@ -6446,7 +6594,7 @@
       </p:sp>
       <p:sp>
         <p:nvSpPr>
-          <p:cNvPr id="77" name="af-svg-text-0021-text-01"/>
+          <p:cNvPr id="77" name="af-svg-text-0021-text-01" descr="{&quot;autofigure_element_id&quot;:&quot;svg-text-0021&quot;}"/>
           <p:cNvSpPr txBox="1"/>
           <p:nvPr/>
         </p:nvSpPr>
@@ -6463,7 +6611,7 @@
         </p:spPr>
         <p:txBody>
           <a:bodyPr wrap="none" anchor="t" lIns="0" rIns="0" tIns="0" bIns="0">
-            <a:spAutoFit/>
+            <a:noAutofit/>
           </a:bodyPr>
           <a:lstStyle/>
           <a:p>
@@ -6482,7 +6630,7 @@
       </p:sp>
       <p:sp>
         <p:nvSpPr>
-          <p:cNvPr id="78" name="af-svg-rect-0034-rect-01"/>
+          <p:cNvPr id="78" name="af-svg-rect-0034-rect-01" descr="{&quot;autofigure_element_id&quot;:&quot;svg-rect-0034&quot;}"/>
           <p:cNvSpPr/>
           <p:nvPr/>
         </p:nvSpPr>
@@ -6503,6 +6651,7 @@
             <a:solidFill>
               <a:srgbClr val="9AB8E0"/>
             </a:solidFill>
+            <a:miter/>
           </a:ln>
           <a:effectLst/>
         </p:spPr>
@@ -6530,7 +6679,7 @@
       </p:sp>
       <p:sp>
         <p:nvSpPr>
-          <p:cNvPr id="79" name="af-svg-text-0022-text-01"/>
+          <p:cNvPr id="79" name="af-svg-text-0022-text-01" descr="{&quot;autofigure_element_id&quot;:&quot;svg-text-0022&quot;}"/>
           <p:cNvSpPr txBox="1"/>
           <p:nvPr/>
         </p:nvSpPr>
@@ -6547,7 +6696,7 @@
         </p:spPr>
         <p:txBody>
           <a:bodyPr wrap="none" anchor="t" lIns="0" rIns="0" tIns="0" bIns="0">
-            <a:spAutoFit/>
+            <a:noAutofit/>
           </a:bodyPr>
           <a:lstStyle/>
           <a:p>
@@ -6566,7 +6715,7 @@
       </p:sp>
       <p:sp>
         <p:nvSpPr>
-          <p:cNvPr id="80" name="af-svg-text-0023-text-01"/>
+          <p:cNvPr id="80" name="af-svg-text-0023-text-01" descr="{&quot;autofigure_element_id&quot;:&quot;svg-text-0023&quot;}"/>
           <p:cNvSpPr txBox="1"/>
           <p:nvPr/>
         </p:nvSpPr>
@@ -6583,7 +6732,7 @@
         </p:spPr>
         <p:txBody>
           <a:bodyPr wrap="none" anchor="t" lIns="0" rIns="0" tIns="0" bIns="0">
-            <a:spAutoFit/>
+            <a:noAutofit/>
           </a:bodyPr>
           <a:lstStyle/>
           <a:p>
@@ -6602,7 +6751,7 @@
       </p:sp>
       <p:sp>
         <p:nvSpPr>
-          <p:cNvPr id="81" name="af-svg-rect-0035-rect-01"/>
+          <p:cNvPr id="81" name="af-svg-rect-0035-rect-01" descr="{&quot;autofigure_element_id&quot;:&quot;svg-rect-0035&quot;}"/>
           <p:cNvSpPr/>
           <p:nvPr/>
         </p:nvSpPr>
@@ -6623,6 +6772,7 @@
             <a:solidFill>
               <a:srgbClr val="1E7FB8"/>
             </a:solidFill>
+            <a:miter/>
           </a:ln>
           <a:effectLst/>
         </p:spPr>
@@ -6650,7 +6800,7 @@
       </p:sp>
       <p:sp>
         <p:nvSpPr>
-          <p:cNvPr id="82" name="af-svg-text-0024-text-01"/>
+          <p:cNvPr id="82" name="af-svg-text-0024-text-01" descr="{&quot;autofigure_element_id&quot;:&quot;svg-text-0024&quot;}"/>
           <p:cNvSpPr txBox="1"/>
           <p:nvPr/>
         </p:nvSpPr>
@@ -6667,7 +6817,7 @@
         </p:spPr>
         <p:txBody>
           <a:bodyPr wrap="none" anchor="t" lIns="0" rIns="0" tIns="0" bIns="0">
-            <a:spAutoFit/>
+            <a:noAutofit/>
           </a:bodyPr>
           <a:lstStyle/>
           <a:p>
@@ -6686,7 +6836,7 @@
       </p:sp>
       <p:sp>
         <p:nvSpPr>
-          <p:cNvPr id="83" name="af-svg-text-0025-text-01"/>
+          <p:cNvPr id="83" name="af-svg-text-0025-text-01" descr="{&quot;autofigure_element_id&quot;:&quot;svg-text-0025&quot;}"/>
           <p:cNvSpPr txBox="1"/>
           <p:nvPr/>
         </p:nvSpPr>
@@ -6703,7 +6853,7 @@
         </p:spPr>
         <p:txBody>
           <a:bodyPr wrap="none" anchor="t" lIns="0" rIns="0" tIns="0" bIns="0">
-            <a:spAutoFit/>
+            <a:noAutofit/>
           </a:bodyPr>
           <a:lstStyle/>
           <a:p>
@@ -6722,7 +6872,7 @@
       </p:sp>
       <p:sp>
         <p:nvSpPr>
-          <p:cNvPr id="84" name="af-svg-text-0026-text-01"/>
+          <p:cNvPr id="84" name="af-svg-text-0026-text-01" descr="{&quot;autofigure_element_id&quot;:&quot;svg-text-0026&quot;}"/>
           <p:cNvSpPr txBox="1"/>
           <p:nvPr/>
         </p:nvSpPr>
@@ -6739,7 +6889,7 @@
         </p:spPr>
         <p:txBody>
           <a:bodyPr wrap="none" anchor="t" lIns="0" rIns="0" tIns="0" bIns="0">
-            <a:spAutoFit/>
+            <a:noAutofit/>
           </a:bodyPr>
           <a:lstStyle/>
           <a:p>
@@ -6758,7 +6908,7 @@
       </p:sp>
       <p:sp>
         <p:nvSpPr>
-          <p:cNvPr id="85" name="af-svg-text-0027-text-01"/>
+          <p:cNvPr id="85" name="af-svg-text-0027-text-01" descr="{&quot;autofigure_element_id&quot;:&quot;svg-text-0027&quot;}"/>
           <p:cNvSpPr txBox="1"/>
           <p:nvPr/>
         </p:nvSpPr>
@@ -6775,7 +6925,7 @@
         </p:spPr>
         <p:txBody>
           <a:bodyPr wrap="none" anchor="t" lIns="0" rIns="0" tIns="0" bIns="0">
-            <a:spAutoFit/>
+            <a:noAutofit/>
           </a:bodyPr>
           <a:lstStyle/>
           <a:p>
@@ -6794,7 +6944,7 @@
       </p:sp>
       <p:sp>
         <p:nvSpPr>
-          <p:cNvPr id="86" name="af-svg-text-0028-text-01"/>
+          <p:cNvPr id="86" name="af-svg-text-0028-text-01" descr="{&quot;autofigure_element_id&quot;:&quot;svg-text-0028&quot;}"/>
           <p:cNvSpPr txBox="1"/>
           <p:nvPr/>
         </p:nvSpPr>
@@ -6811,7 +6961,7 @@
         </p:spPr>
         <p:txBody>
           <a:bodyPr wrap="none" anchor="t" lIns="0" rIns="0" tIns="0" bIns="0">
-            <a:spAutoFit/>
+            <a:noAutofit/>
           </a:bodyPr>
           <a:lstStyle/>
           <a:p>
@@ -6830,7 +6980,7 @@
       </p:sp>
       <p:sp>
         <p:nvSpPr>
-          <p:cNvPr id="87" name="af-svg-text-0029-text-01"/>
+          <p:cNvPr id="87" name="af-svg-text-0029-text-01" descr="{&quot;autofigure_element_id&quot;:&quot;svg-text-0029&quot;}"/>
           <p:cNvSpPr txBox="1"/>
           <p:nvPr/>
         </p:nvSpPr>
@@ -6847,7 +6997,7 @@
         </p:spPr>
         <p:txBody>
           <a:bodyPr wrap="none" anchor="t" lIns="0" rIns="0" tIns="0" bIns="0">
-            <a:spAutoFit/>
+            <a:noAutofit/>
           </a:bodyPr>
           <a:lstStyle/>
           <a:p>
@@ -6866,14 +7016,14 @@
       </p:sp>
       <p:sp>
         <p:nvSpPr>
-          <p:cNvPr id="88" name="af-svg-path-0008-freeform-01"/>
+          <p:cNvPr id="88" name="af-brace-top-right-image-freeform-01" descr="{&quot;autofigure_element_id&quot;:&quot;brace-top-right-image&quot;,&quot;brace_spec_sha256&quot;:&quot;d05155485ade0decfedb8588bd0d048b5426fca0f64a43989706076d9a10b77e&quot;,&quot;primitive_spec_sha256&quot;:&quot;d05155485ade0decfedb8588bd0d048b5426fca0f64a43989706076d9a10b77e&quot;}"/>
           <p:cNvSpPr/>
           <p:nvPr/>
         </p:nvSpPr>
         <p:spPr>
           <a:xfrm>
-            <a:off x="7400925" y="333375"/>
-            <a:ext cx="1162050" cy="123825"/>
+            <a:off x="7620000" y="342900"/>
+            <a:ext cx="1009650" cy="133350"/>
           </a:xfrm>
           <a:custGeom>
             <a:avLst/>
@@ -6882,57 +7032,73 @@
             <a:cxnLst/>
             <a:rect l="0" t="0" r="0" b="0"/>
             <a:pathLst>
-              <a:path w="1162050" h="123825">
+              <a:path w="1009650" h="133350">
                 <a:moveTo>
-                  <a:pt x="0" y="123825"/>
+                  <a:pt x="0" y="133350"/>
                 </a:moveTo>
+                <a:lnTo>
+                  <a:pt x="0" y="95250"/>
+                </a:lnTo>
                 <a:cubicBezTo>
-                  <a:pt x="0" y="57150"/>
-                  <a:pt x="19050" y="47625"/>
-                  <a:pt x="66675" y="47625"/>
+                  <a:pt x="0" y="69850"/>
+                  <a:pt x="19050" y="57150"/>
+                  <a:pt x="57150" y="57150"/>
                 </a:cubicBezTo>
                 <a:lnTo>
-                  <a:pt x="495300" y="47625"/>
+                  <a:pt x="457200" y="57150"/>
                 </a:lnTo>
                 <a:cubicBezTo>
-                  <a:pt x="508000" y="15875"/>
-                  <a:pt x="536575" y="0"/>
-                  <a:pt x="581025" y="0"/>
-                </a:cubicBezTo>
-                <a:cubicBezTo>
-                  <a:pt x="625475" y="0"/>
-                  <a:pt x="654050" y="15875"/>
-                  <a:pt x="666750" y="47625"/>
+                  <a:pt x="488950" y="57150"/>
+                  <a:pt x="504825" y="47625"/>
+                  <a:pt x="504825" y="28575"/>
                 </a:cubicBezTo>
                 <a:lnTo>
-                  <a:pt x="1095375" y="47625"/>
+                  <a:pt x="504825" y="0"/>
+                </a:lnTo>
+                <a:moveTo>
+                  <a:pt x="504825" y="0"/>
+                </a:moveTo>
+                <a:lnTo>
+                  <a:pt x="504825" y="28575"/>
                 </a:lnTo>
                 <a:cubicBezTo>
-                  <a:pt x="1143000" y="47625"/>
-                  <a:pt x="1162050" y="57150"/>
-                  <a:pt x="1162050" y="123825"/>
+                  <a:pt x="504825" y="47625"/>
+                  <a:pt x="520700" y="57150"/>
+                  <a:pt x="552450" y="57150"/>
                 </a:cubicBezTo>
+                <a:lnTo>
+                  <a:pt x="952500" y="57150"/>
+                </a:lnTo>
+                <a:cubicBezTo>
+                  <a:pt x="990600" y="57150"/>
+                  <a:pt x="1009650" y="69850"/>
+                  <a:pt x="1009650" y="95250"/>
+                </a:cubicBezTo>
+                <a:lnTo>
+                  <a:pt x="1009650" y="133350"/>
+                </a:lnTo>
               </a:path>
             </a:pathLst>
           </a:custGeom>
           <a:noFill/>
-          <a:ln w="14288">
+          <a:ln w="9525" cap="rnd">
             <a:solidFill>
               <a:srgbClr val="333333"/>
             </a:solidFill>
-          </a:ln>
-        </p:spPr>
-      </p:sp>
-      <p:sp>
-        <p:nvSpPr>
-          <p:cNvPr id="89" name="af-svg-path-0009-freeform-01"/>
+            <a:miter/>
+          </a:ln>
+        </p:spPr>
+      </p:sp>
+      <p:sp>
+        <p:nvSpPr>
+          <p:cNvPr id="89" name="af-brace-top-right-prompt-freeform-01" descr="{&quot;autofigure_element_id&quot;:&quot;brace-top-right-prompt&quot;,&quot;brace_spec_sha256&quot;:&quot;70001b40e30efd9956ba25043546a4f497dc07a329bf7d203e5d9500bb5cbacc&quot;,&quot;primitive_spec_sha256&quot;:&quot;70001b40e30efd9956ba25043546a4f497dc07a329bf7d203e5d9500bb5cbacc&quot;}"/>
           <p:cNvSpPr/>
           <p:nvPr/>
         </p:nvSpPr>
         <p:spPr>
           <a:xfrm>
-            <a:off x="8743950" y="333375"/>
-            <a:ext cx="1162050" cy="123825"/>
+            <a:off x="8972550" y="333375"/>
+            <a:ext cx="1009650" cy="152400"/>
           </a:xfrm>
           <a:custGeom>
             <a:avLst/>
@@ -6941,57 +7107,73 @@
             <a:cxnLst/>
             <a:rect l="0" t="0" r="0" b="0"/>
             <a:pathLst>
-              <a:path w="1162050" h="123825">
+              <a:path w="1009650" h="152400">
                 <a:moveTo>
-                  <a:pt x="0" y="123825"/>
+                  <a:pt x="0" y="152400"/>
                 </a:moveTo>
+                <a:lnTo>
+                  <a:pt x="0" y="114300"/>
+                </a:lnTo>
                 <a:cubicBezTo>
-                  <a:pt x="0" y="57150"/>
-                  <a:pt x="19050" y="47625"/>
-                  <a:pt x="66675" y="47625"/>
+                  <a:pt x="0" y="82550"/>
+                  <a:pt x="19050" y="66675"/>
+                  <a:pt x="57150" y="66675"/>
                 </a:cubicBezTo>
                 <a:lnTo>
-                  <a:pt x="495300" y="47625"/>
+                  <a:pt x="457200" y="66675"/>
                 </a:lnTo>
                 <a:cubicBezTo>
-                  <a:pt x="508000" y="15875"/>
-                  <a:pt x="536575" y="0"/>
-                  <a:pt x="581025" y="0"/>
-                </a:cubicBezTo>
-                <a:cubicBezTo>
-                  <a:pt x="625475" y="0"/>
-                  <a:pt x="654050" y="15875"/>
-                  <a:pt x="666750" y="47625"/>
+                  <a:pt x="488950" y="66675"/>
+                  <a:pt x="504825" y="53975"/>
+                  <a:pt x="504825" y="28575"/>
                 </a:cubicBezTo>
                 <a:lnTo>
-                  <a:pt x="1095375" y="47625"/>
+                  <a:pt x="504825" y="0"/>
+                </a:lnTo>
+                <a:moveTo>
+                  <a:pt x="504825" y="0"/>
+                </a:moveTo>
+                <a:lnTo>
+                  <a:pt x="504825" y="28575"/>
                 </a:lnTo>
                 <a:cubicBezTo>
-                  <a:pt x="1143000" y="47625"/>
-                  <a:pt x="1162050" y="57150"/>
-                  <a:pt x="1162050" y="123825"/>
+                  <a:pt x="504825" y="53975"/>
+                  <a:pt x="520700" y="66675"/>
+                  <a:pt x="552450" y="66675"/>
                 </a:cubicBezTo>
+                <a:lnTo>
+                  <a:pt x="952500" y="66675"/>
+                </a:lnTo>
+                <a:cubicBezTo>
+                  <a:pt x="990600" y="66675"/>
+                  <a:pt x="1009650" y="82550"/>
+                  <a:pt x="1009650" y="114300"/>
+                </a:cubicBezTo>
+                <a:lnTo>
+                  <a:pt x="1009650" y="152400"/>
+                </a:lnTo>
               </a:path>
             </a:pathLst>
           </a:custGeom>
           <a:noFill/>
-          <a:ln w="14288">
+          <a:ln w="9525" cap="rnd">
             <a:solidFill>
               <a:srgbClr val="333333"/>
             </a:solidFill>
-          </a:ln>
-        </p:spPr>
-      </p:sp>
-      <p:sp>
-        <p:nvSpPr>
-          <p:cNvPr id="90" name="af-svg-path-0010-freeform-01"/>
+            <a:miter/>
+          </a:ln>
+        </p:spPr>
+      </p:sp>
+      <p:sp>
+        <p:nvSpPr>
+          <p:cNvPr id="90" name="af-brace-top-right-response-freeform-01" descr="{&quot;autofigure_element_id&quot;:&quot;brace-top-right-response&quot;,&quot;brace_spec_sha256&quot;:&quot;299d9c484ba8d7ce5aa0938b40a49c8a4e0ed7004a58e0c34c478045ce8866cf&quot;,&quot;primitive_spec_sha256&quot;:&quot;299d9c484ba8d7ce5aa0938b40a49c8a4e0ed7004a58e0c34c478045ce8866cf&quot;}"/>
           <p:cNvSpPr/>
           <p:nvPr/>
         </p:nvSpPr>
         <p:spPr>
           <a:xfrm>
-            <a:off x="10067925" y="333375"/>
-            <a:ext cx="3524250" cy="123825"/>
+            <a:off x="10315575" y="333375"/>
+            <a:ext cx="3352800" cy="152400"/>
           </a:xfrm>
           <a:custGeom>
             <a:avLst/>
@@ -7000,50 +7182,66 @@
             <a:cxnLst/>
             <a:rect l="0" t="0" r="0" b="0"/>
             <a:pathLst>
-              <a:path w="3524250" h="123825">
+              <a:path w="3352800" h="152400">
                 <a:moveTo>
-                  <a:pt x="0" y="123825"/>
+                  <a:pt x="0" y="152400"/>
                 </a:moveTo>
+                <a:lnTo>
+                  <a:pt x="0" y="114300"/>
+                </a:lnTo>
                 <a:cubicBezTo>
-                  <a:pt x="0" y="57150"/>
-                  <a:pt x="19050" y="47625"/>
-                  <a:pt x="66675" y="47625"/>
+                  <a:pt x="0" y="82550"/>
+                  <a:pt x="19050" y="66675"/>
+                  <a:pt x="57150" y="66675"/>
                 </a:cubicBezTo>
                 <a:lnTo>
-                  <a:pt x="1695450" y="47625"/>
+                  <a:pt x="1628775" y="66675"/>
                 </a:lnTo>
                 <a:cubicBezTo>
-                  <a:pt x="1708150" y="15875"/>
-                  <a:pt x="1736725" y="0"/>
-                  <a:pt x="1781175" y="0"/>
-                </a:cubicBezTo>
-                <a:cubicBezTo>
-                  <a:pt x="1825625" y="0"/>
-                  <a:pt x="1854200" y="15875"/>
-                  <a:pt x="1866900" y="47625"/>
+                  <a:pt x="1660525" y="66675"/>
+                  <a:pt x="1676400" y="53975"/>
+                  <a:pt x="1676400" y="28575"/>
                 </a:cubicBezTo>
                 <a:lnTo>
-                  <a:pt x="3457575" y="47625"/>
+                  <a:pt x="1676400" y="0"/>
+                </a:lnTo>
+                <a:moveTo>
+                  <a:pt x="1676400" y="0"/>
+                </a:moveTo>
+                <a:lnTo>
+                  <a:pt x="1676400" y="28575"/>
                 </a:lnTo>
                 <a:cubicBezTo>
-                  <a:pt x="3505200" y="47625"/>
-                  <a:pt x="3524250" y="57150"/>
-                  <a:pt x="3524250" y="123825"/>
+                  <a:pt x="1676400" y="53975"/>
+                  <a:pt x="1692275" y="66675"/>
+                  <a:pt x="1724025" y="66675"/>
                 </a:cubicBezTo>
+                <a:lnTo>
+                  <a:pt x="3295650" y="66675"/>
+                </a:lnTo>
+                <a:cubicBezTo>
+                  <a:pt x="3333750" y="66675"/>
+                  <a:pt x="3352800" y="82550"/>
+                  <a:pt x="3352800" y="114300"/>
+                </a:cubicBezTo>
+                <a:lnTo>
+                  <a:pt x="3352800" y="152400"/>
+                </a:lnTo>
               </a:path>
             </a:pathLst>
           </a:custGeom>
           <a:noFill/>
-          <a:ln w="14288">
+          <a:ln w="9525" cap="rnd">
             <a:solidFill>
               <a:srgbClr val="333333"/>
             </a:solidFill>
-          </a:ln>
-        </p:spPr>
-      </p:sp>
-      <p:sp>
-        <p:nvSpPr>
-          <p:cNvPr id="91" name="af-svg-rect-0036-rect-01"/>
+            <a:miter/>
+          </a:ln>
+        </p:spPr>
+      </p:sp>
+      <p:sp>
+        <p:nvSpPr>
+          <p:cNvPr id="91" name="af-svg-rect-0036-rect-01" descr="{&quot;autofigure_element_id&quot;:&quot;svg-rect-0036&quot;}"/>
           <p:cNvSpPr/>
           <p:nvPr/>
         </p:nvSpPr>
@@ -7064,6 +7262,7 @@
             <a:solidFill>
               <a:srgbClr val="E0D5B8"/>
             </a:solidFill>
+            <a:miter/>
           </a:ln>
           <a:effectLst/>
         </p:spPr>
@@ -7091,7 +7290,7 @@
       </p:sp>
       <p:sp>
         <p:nvSpPr>
-          <p:cNvPr id="92" name="af-svg-rect-0037-rect-01"/>
+          <p:cNvPr id="92" name="af-svg-rect-0037-rect-01" descr="{&quot;autofigure_element_id&quot;:&quot;svg-rect-0037&quot;}"/>
           <p:cNvSpPr/>
           <p:nvPr/>
         </p:nvSpPr>
@@ -7112,6 +7311,7 @@
             <a:solidFill>
               <a:srgbClr val="E0D5B8"/>
             </a:solidFill>
+            <a:miter/>
           </a:ln>
           <a:effectLst/>
         </p:spPr>
@@ -7139,7 +7339,7 @@
       </p:sp>
       <p:sp>
         <p:nvSpPr>
-          <p:cNvPr id="93" name="af-svg-rect-0038-rect-01"/>
+          <p:cNvPr id="93" name="af-svg-rect-0038-rect-01" descr="{&quot;autofigure_element_id&quot;:&quot;svg-rect-0038&quot;}"/>
           <p:cNvSpPr/>
           <p:nvPr/>
         </p:nvSpPr>
@@ -7160,6 +7360,7 @@
             <a:solidFill>
               <a:srgbClr val="E0D5B8"/>
             </a:solidFill>
+            <a:miter/>
           </a:ln>
           <a:effectLst/>
         </p:spPr>
@@ -7187,7 +7388,7 @@
       </p:sp>
       <p:sp>
         <p:nvSpPr>
-          <p:cNvPr id="94" name="af-svg-rect-0039-rect-01"/>
+          <p:cNvPr id="94" name="af-svg-rect-0039-rect-01" descr="{&quot;autofigure_element_id&quot;:&quot;svg-rect-0039&quot;}"/>
           <p:cNvSpPr/>
           <p:nvPr/>
         </p:nvSpPr>
@@ -7208,6 +7409,7 @@
             <a:solidFill>
               <a:srgbClr val="97C794"/>
             </a:solidFill>
+            <a:miter/>
           </a:ln>
           <a:effectLst/>
         </p:spPr>
@@ -7235,7 +7437,7 @@
       </p:sp>
       <p:sp>
         <p:nvSpPr>
-          <p:cNvPr id="95" name="af-svg-rect-0040-rect-01"/>
+          <p:cNvPr id="95" name="af-svg-rect-0040-rect-01" descr="{&quot;autofigure_element_id&quot;:&quot;svg-rect-0040&quot;}"/>
           <p:cNvSpPr/>
           <p:nvPr/>
         </p:nvSpPr>
@@ -7256,6 +7458,7 @@
             <a:solidFill>
               <a:srgbClr val="97C794"/>
             </a:solidFill>
+            <a:miter/>
           </a:ln>
           <a:effectLst/>
         </p:spPr>
@@ -7283,7 +7486,7 @@
       </p:sp>
       <p:sp>
         <p:nvSpPr>
-          <p:cNvPr id="96" name="af-svg-rect-0041-rect-01"/>
+          <p:cNvPr id="96" name="af-svg-rect-0041-rect-01" descr="{&quot;autofigure_element_id&quot;:&quot;svg-rect-0041&quot;}"/>
           <p:cNvSpPr/>
           <p:nvPr/>
         </p:nvSpPr>
@@ -7304,6 +7507,7 @@
             <a:solidFill>
               <a:srgbClr val="97C794"/>
             </a:solidFill>
+            <a:miter/>
           </a:ln>
           <a:effectLst/>
         </p:spPr>
@@ -7331,7 +7535,7 @@
       </p:sp>
       <p:sp>
         <p:nvSpPr>
-          <p:cNvPr id="97" name="af-svg-rect-0042-rect-01"/>
+          <p:cNvPr id="97" name="af-svg-rect-0042-rect-01" descr="{&quot;autofigure_element_id&quot;:&quot;svg-rect-0042&quot;}"/>
           <p:cNvSpPr/>
           <p:nvPr/>
         </p:nvSpPr>
@@ -7352,6 +7556,7 @@
             <a:solidFill>
               <a:srgbClr val="B3B3B3"/>
             </a:solidFill>
+            <a:miter/>
           </a:ln>
           <a:effectLst/>
         </p:spPr>
@@ -7379,7 +7584,7 @@
       </p:sp>
       <p:sp>
         <p:nvSpPr>
-          <p:cNvPr id="98" name="af-svg-rect-0043-rect-01"/>
+          <p:cNvPr id="98" name="af-svg-rect-0043-rect-01" descr="{&quot;autofigure_element_id&quot;:&quot;svg-rect-0043&quot;}"/>
           <p:cNvSpPr/>
           <p:nvPr/>
         </p:nvSpPr>
@@ -7400,6 +7605,7 @@
             <a:solidFill>
               <a:srgbClr val="B3B3B3"/>
             </a:solidFill>
+            <a:miter/>
           </a:ln>
           <a:effectLst/>
         </p:spPr>
@@ -7427,7 +7633,7 @@
       </p:sp>
       <p:sp>
         <p:nvSpPr>
-          <p:cNvPr id="99" name="af-svg-rect-0044-rect-01"/>
+          <p:cNvPr id="99" name="af-svg-rect-0044-rect-01" descr="{&quot;autofigure_element_id&quot;:&quot;svg-rect-0044&quot;}"/>
           <p:cNvSpPr/>
           <p:nvPr/>
         </p:nvSpPr>
@@ -7448,6 +7654,7 @@
             <a:solidFill>
               <a:srgbClr val="B3B3B3"/>
             </a:solidFill>
+            <a:miter/>
           </a:ln>
           <a:effectLst/>
         </p:spPr>
@@ -7475,7 +7682,7 @@
       </p:sp>
       <p:sp>
         <p:nvSpPr>
-          <p:cNvPr id="100" name="af-svg-rect-0045-rect-01"/>
+          <p:cNvPr id="100" name="af-svg-rect-0045-rect-01" descr="{&quot;autofigure_element_id&quot;:&quot;svg-rect-0045&quot;}"/>
           <p:cNvSpPr/>
           <p:nvPr/>
         </p:nvSpPr>
@@ -7496,6 +7703,7 @@
             <a:solidFill>
               <a:srgbClr val="B3B3B3"/>
             </a:solidFill>
+            <a:miter/>
           </a:ln>
           <a:effectLst/>
         </p:spPr>
@@ -7523,7 +7731,7 @@
       </p:sp>
       <p:sp>
         <p:nvSpPr>
-          <p:cNvPr id="101" name="af-svg-circle-0013-ellipse-01"/>
+          <p:cNvPr id="101" name="af-svg-circle-0013-ellipse-01" descr="{&quot;autofigure_element_id&quot;:&quot;svg-circle-0013&quot;}"/>
           <p:cNvSpPr/>
           <p:nvPr/>
         </p:nvSpPr>
@@ -7567,7 +7775,7 @@
       </p:sp>
       <p:sp>
         <p:nvSpPr>
-          <p:cNvPr id="102" name="af-svg-circle-0014-ellipse-01"/>
+          <p:cNvPr id="102" name="af-svg-circle-0014-ellipse-01" descr="{&quot;autofigure_element_id&quot;:&quot;svg-circle-0014&quot;}"/>
           <p:cNvSpPr/>
           <p:nvPr/>
         </p:nvSpPr>
@@ -7611,7 +7819,7 @@
       </p:sp>
       <p:sp>
         <p:nvSpPr>
-          <p:cNvPr id="103" name="af-svg-circle-0015-ellipse-01"/>
+          <p:cNvPr id="103" name="af-svg-circle-0015-ellipse-01" descr="{&quot;autofigure_element_id&quot;:&quot;svg-circle-0015&quot;}"/>
           <p:cNvSpPr/>
           <p:nvPr/>
         </p:nvSpPr>
@@ -7655,7 +7863,7 @@
       </p:sp>
       <p:sp>
         <p:nvSpPr>
-          <p:cNvPr id="104" name="af-svg-rect-0046-rect-01"/>
+          <p:cNvPr id="104" name="af-svg-rect-0046-rect-01" descr="{&quot;autofigure_element_id&quot;:&quot;svg-rect-0046&quot;}"/>
           <p:cNvSpPr/>
           <p:nvPr/>
         </p:nvSpPr>
@@ -7676,6 +7884,7 @@
             <a:solidFill>
               <a:srgbClr val="B3B3B3"/>
             </a:solidFill>
+            <a:miter/>
           </a:ln>
           <a:effectLst/>
         </p:spPr>
@@ -7703,7 +7912,7 @@
       </p:sp>
       <p:sp>
         <p:nvSpPr>
-          <p:cNvPr id="105" name="af-svg-rect-0047-rect-01"/>
+          <p:cNvPr id="105" name="af-svg-rect-0047-rect-01" descr="{&quot;autofigure_element_id&quot;:&quot;svg-rect-0047&quot;}"/>
           <p:cNvSpPr/>
           <p:nvPr/>
         </p:nvSpPr>
@@ -7724,6 +7933,7 @@
             <a:solidFill>
               <a:srgbClr val="B3B3B3"/>
             </a:solidFill>
+            <a:miter/>
           </a:ln>
           <a:effectLst/>
         </p:spPr>
@@ -7751,7 +7961,7 @@
       </p:sp>
       <p:sp>
         <p:nvSpPr>
-          <p:cNvPr id="106" name="af-svg-rect-0048-rect-01"/>
+          <p:cNvPr id="106" name="af-svg-rect-0048-rect-01" descr="{&quot;autofigure_element_id&quot;:&quot;svg-rect-0048&quot;}"/>
           <p:cNvSpPr/>
           <p:nvPr/>
         </p:nvSpPr>
@@ -7772,6 +7982,7 @@
             <a:solidFill>
               <a:srgbClr val="B3B3B3"/>
             </a:solidFill>
+            <a:miter/>
           </a:ln>
           <a:effectLst/>
         </p:spPr>
@@ -7799,7 +8010,7 @@
       </p:sp>
       <p:sp>
         <p:nvSpPr>
-          <p:cNvPr id="107" name="af-svg-rect-0049-rect-01"/>
+          <p:cNvPr id="107" name="af-svg-rect-0049-rect-01" descr="{&quot;autofigure_element_id&quot;:&quot;svg-rect-0049&quot;}"/>
           <p:cNvSpPr/>
           <p:nvPr/>
         </p:nvSpPr>
@@ -7820,6 +8031,7 @@
             <a:solidFill>
               <a:srgbClr val="B3B3B3"/>
             </a:solidFill>
+            <a:miter/>
           </a:ln>
           <a:effectLst/>
         </p:spPr>
@@ -7847,22 +8059,23 @@
       </p:sp>
       <p:cxnSp>
         <p:nvCxnSpPr>
-          <p:cNvPr id="108" name="af-svg-line-0004-connector-01"/>
+          <p:cNvPr id="108" name="af-arrow-right-input-to-model-connector-01" descr="{&quot;arrow_spec_sha256&quot;:&quot;d9d2990749d4db18c0f9d45867d0fa1035aff65a9a51f3eb016c2b75d024da53&quot;,&quot;autofigure_element_id&quot;:&quot;arrow-right-input-to-model&quot;}"/>
           <p:cNvCxnSpPr/>
           <p:nvPr/>
         </p:nvCxnSpPr>
         <p:spPr>
           <a:xfrm>
-            <a:off x="11849100" y="904875"/>
-            <a:ext cx="0" cy="219075"/>
+            <a:off x="12001500" y="838200"/>
+            <a:ext cx="0" cy="228600"/>
           </a:xfrm>
           <a:prstGeom prst="line">
             <a:avLst/>
           </a:prstGeom>
           <a:ln w="19050">
             <a:solidFill>
-              <a:srgbClr val="333333"/>
+              <a:srgbClr val="000000"/>
             </a:solidFill>
+            <a:miter/>
             <a:tailEnd type="triangle" w="med" len="med"/>
           </a:ln>
           <a:effectLst/>
@@ -7884,7 +8097,7 @@
       </p:cxnSp>
       <p:sp>
         <p:nvSpPr>
-          <p:cNvPr id="109" name="af-svg-rect-0050-rect-01"/>
+          <p:cNvPr id="109" name="af-svg-rect-0050-rect-01" descr="{&quot;autofigure_element_id&quot;:&quot;svg-rect-0050&quot;}"/>
           <p:cNvSpPr/>
           <p:nvPr/>
         </p:nvSpPr>
@@ -7905,6 +8118,7 @@
             <a:solidFill>
               <a:srgbClr val="DCA3A3"/>
             </a:solidFill>
+            <a:miter/>
           </a:ln>
           <a:effectLst/>
         </p:spPr>
@@ -7932,7 +8146,7 @@
       </p:sp>
       <p:sp>
         <p:nvSpPr>
-          <p:cNvPr id="110" name="af-svg-text-0030-text-01"/>
+          <p:cNvPr id="110" name="af-svg-text-0030-text-01" descr="{&quot;autofigure_element_id&quot;:&quot;svg-text-0030&quot;}"/>
           <p:cNvSpPr txBox="1"/>
           <p:nvPr/>
         </p:nvSpPr>
@@ -7949,7 +8163,7 @@
         </p:spPr>
         <p:txBody>
           <a:bodyPr wrap="none" anchor="t" lIns="0" rIns="0" tIns="0" bIns="0">
-            <a:spAutoFit/>
+            <a:noAutofit/>
           </a:bodyPr>
           <a:lstStyle/>
           <a:p>
@@ -7968,22 +8182,23 @@
       </p:sp>
       <p:cxnSp>
         <p:nvCxnSpPr>
-          <p:cNvPr id="111" name="af-svg-line-0005-connector-01"/>
+          <p:cNvPr id="111" name="af-arrow-right-model-to-early-step-connector-01" descr="{&quot;arrow_spec_sha256&quot;:&quot;ea2d49f84482f4086ef839b0e6351c249977a2d2322b9c9d68623cd4604c8b9c&quot;,&quot;autofigure_element_id&quot;:&quot;arrow-right-model-to-early-step&quot;}"/>
           <p:cNvCxnSpPr/>
           <p:nvPr/>
         </p:nvCxnSpPr>
         <p:spPr>
           <a:xfrm>
-            <a:off x="11972925" y="1581150"/>
-            <a:ext cx="0" cy="304800"/>
+            <a:off x="12001500" y="1733550"/>
+            <a:ext cx="0" cy="485775"/>
           </a:xfrm>
           <a:prstGeom prst="line">
             <a:avLst/>
           </a:prstGeom>
           <a:ln w="19050">
             <a:solidFill>
-              <a:srgbClr val="333333"/>
+              <a:srgbClr val="000000"/>
             </a:solidFill>
+            <a:miter/>
             <a:tailEnd type="triangle" w="med" len="med"/>
           </a:ln>
           <a:effectLst/>
@@ -8005,7 +8220,7 @@
       </p:cxnSp>
       <p:sp>
         <p:nvSpPr>
-          <p:cNvPr id="112" name="af-svg-text-0031-text-01"/>
+          <p:cNvPr id="112" name="af-svg-text-0031-text-01" descr="{&quot;autofigure_element_id&quot;:&quot;svg-text-0031&quot;}"/>
           <p:cNvSpPr txBox="1"/>
           <p:nvPr/>
         </p:nvSpPr>
@@ -8022,7 +8237,7 @@
         </p:spPr>
         <p:txBody>
           <a:bodyPr wrap="none" anchor="t" lIns="0" rIns="0" tIns="0" bIns="0">
-            <a:spAutoFit/>
+            <a:noAutofit/>
           </a:bodyPr>
           <a:lstStyle/>
           <a:p>
@@ -8041,7 +8256,7 @@
       </p:sp>
       <p:sp>
         <p:nvSpPr>
-          <p:cNvPr id="113" name="af-svg-rect-0051-rect-01"/>
+          <p:cNvPr id="113" name="af-svg-rect-0051-rect-01" descr="{&quot;autofigure_element_id&quot;:&quot;svg-rect-0051&quot;}"/>
           <p:cNvSpPr/>
           <p:nvPr/>
         </p:nvSpPr>
@@ -8062,6 +8277,7 @@
             <a:solidFill>
               <a:srgbClr val="B3B3B3"/>
             </a:solidFill>
+            <a:miter/>
           </a:ln>
           <a:effectLst/>
         </p:spPr>
@@ -8089,7 +8305,7 @@
       </p:sp>
       <p:sp>
         <p:nvSpPr>
-          <p:cNvPr id="114" name="af-svg-rect-0052-rect-01"/>
+          <p:cNvPr id="114" name="af-svg-rect-0052-rect-01" descr="{&quot;autofigure_element_id&quot;:&quot;svg-rect-0052&quot;}"/>
           <p:cNvSpPr/>
           <p:nvPr/>
         </p:nvSpPr>
@@ -8110,6 +8326,7 @@
             <a:solidFill>
               <a:srgbClr val="1E7FB8"/>
             </a:solidFill>
+            <a:miter/>
           </a:ln>
           <a:effectLst/>
         </p:spPr>
@@ -8137,7 +8354,7 @@
       </p:sp>
       <p:sp>
         <p:nvSpPr>
-          <p:cNvPr id="115" name="af-svg-rect-0053-rect-01"/>
+          <p:cNvPr id="115" name="af-svg-rect-0053-rect-01" descr="{&quot;autofigure_element_id&quot;:&quot;svg-rect-0053&quot;}"/>
           <p:cNvSpPr/>
           <p:nvPr/>
         </p:nvSpPr>
@@ -8158,6 +8375,7 @@
             <a:solidFill>
               <a:srgbClr val="B3B3B3"/>
             </a:solidFill>
+            <a:miter/>
           </a:ln>
           <a:effectLst/>
         </p:spPr>
@@ -8185,7 +8403,7 @@
       </p:sp>
       <p:sp>
         <p:nvSpPr>
-          <p:cNvPr id="116" name="af-svg-rect-0054-rect-01"/>
+          <p:cNvPr id="116" name="af-svg-rect-0054-rect-01" descr="{&quot;autofigure_element_id&quot;:&quot;svg-rect-0054&quot;}"/>
           <p:cNvSpPr/>
           <p:nvPr/>
         </p:nvSpPr>
@@ -8206,6 +8424,7 @@
             <a:solidFill>
               <a:srgbClr val="1E7FB8"/>
             </a:solidFill>
+            <a:miter/>
           </a:ln>
           <a:effectLst/>
         </p:spPr>
@@ -8233,7 +8452,7 @@
       </p:sp>
       <p:sp>
         <p:nvSpPr>
-          <p:cNvPr id="117" name="af-svg-circle-0016-ellipse-01"/>
+          <p:cNvPr id="117" name="af-svg-circle-0016-ellipse-01" descr="{&quot;autofigure_element_id&quot;:&quot;svg-circle-0016&quot;}"/>
           <p:cNvSpPr/>
           <p:nvPr/>
         </p:nvSpPr>
@@ -8277,7 +8496,7 @@
       </p:sp>
       <p:sp>
         <p:nvSpPr>
-          <p:cNvPr id="118" name="af-svg-circle-0017-ellipse-01"/>
+          <p:cNvPr id="118" name="af-svg-circle-0017-ellipse-01" descr="{&quot;autofigure_element_id&quot;:&quot;svg-circle-0017&quot;}"/>
           <p:cNvSpPr/>
           <p:nvPr/>
         </p:nvSpPr>
@@ -8321,7 +8540,7 @@
       </p:sp>
       <p:sp>
         <p:nvSpPr>
-          <p:cNvPr id="119" name="af-svg-circle-0018-ellipse-01"/>
+          <p:cNvPr id="119" name="af-svg-circle-0018-ellipse-01" descr="{&quot;autofigure_element_id&quot;:&quot;svg-circle-0018&quot;}"/>
           <p:cNvSpPr/>
           <p:nvPr/>
         </p:nvSpPr>
@@ -8365,7 +8584,7 @@
       </p:sp>
       <p:sp>
         <p:nvSpPr>
-          <p:cNvPr id="120" name="af-svg-rect-0055-rect-01"/>
+          <p:cNvPr id="120" name="af-svg-rect-0055-rect-01" descr="{&quot;autofigure_element_id&quot;:&quot;svg-rect-0055&quot;}"/>
           <p:cNvSpPr/>
           <p:nvPr/>
         </p:nvSpPr>
@@ -8386,6 +8605,7 @@
             <a:solidFill>
               <a:srgbClr val="B3B3B3"/>
             </a:solidFill>
+            <a:miter/>
           </a:ln>
           <a:effectLst/>
         </p:spPr>
@@ -8413,7 +8633,7 @@
       </p:sp>
       <p:sp>
         <p:nvSpPr>
-          <p:cNvPr id="121" name="af-svg-rect-0056-rect-01"/>
+          <p:cNvPr id="121" name="af-svg-rect-0056-rect-01" descr="{&quot;autofigure_element_id&quot;:&quot;svg-rect-0056&quot;}"/>
           <p:cNvSpPr/>
           <p:nvPr/>
         </p:nvSpPr>
@@ -8434,6 +8654,7 @@
             <a:solidFill>
               <a:srgbClr val="B3B3B3"/>
             </a:solidFill>
+            <a:miter/>
           </a:ln>
           <a:effectLst/>
         </p:spPr>
@@ -8461,7 +8682,7 @@
       </p:sp>
       <p:sp>
         <p:nvSpPr>
-          <p:cNvPr id="122" name="af-svg-rect-0057-rect-01"/>
+          <p:cNvPr id="122" name="af-svg-rect-0057-rect-01" descr="{&quot;autofigure_element_id&quot;:&quot;svg-rect-0057&quot;}"/>
           <p:cNvSpPr/>
           <p:nvPr/>
         </p:nvSpPr>
@@ -8482,6 +8703,7 @@
             <a:solidFill>
               <a:srgbClr val="B3B3B3"/>
             </a:solidFill>
+            <a:miter/>
           </a:ln>
           <a:effectLst/>
         </p:spPr>
@@ -8509,7 +8731,7 @@
       </p:sp>
       <p:sp>
         <p:nvSpPr>
-          <p:cNvPr id="123" name="af-svg-rect-0058-rect-01"/>
+          <p:cNvPr id="123" name="af-svg-rect-0058-rect-01" descr="{&quot;autofigure_element_id&quot;:&quot;svg-rect-0058&quot;}"/>
           <p:cNvSpPr/>
           <p:nvPr/>
         </p:nvSpPr>
@@ -8530,6 +8752,7 @@
             <a:solidFill>
               <a:srgbClr val="B3B3B3"/>
             </a:solidFill>
+            <a:miter/>
           </a:ln>
           <a:effectLst/>
         </p:spPr>
@@ -8557,7 +8780,7 @@
       </p:sp>
       <p:sp>
         <p:nvSpPr>
-          <p:cNvPr id="124" name="af-svg-text-0032-text-01"/>
+          <p:cNvPr id="124" name="af-svg-text-0032-text-01" descr="{&quot;autofigure_element_id&quot;:&quot;svg-text-0032&quot;}"/>
           <p:cNvSpPr txBox="1"/>
           <p:nvPr/>
         </p:nvSpPr>
@@ -8574,7 +8797,7 @@
         </p:spPr>
         <p:txBody>
           <a:bodyPr wrap="none" anchor="t" lIns="0" rIns="0" tIns="0" bIns="0">
-            <a:spAutoFit/>
+            <a:noAutofit/>
           </a:bodyPr>
           <a:lstStyle/>
           <a:p>
@@ -8593,7 +8816,7 @@
       </p:sp>
       <p:sp>
         <p:nvSpPr>
-          <p:cNvPr id="125" name="af-svg-text-0033-text-01"/>
+          <p:cNvPr id="125" name="af-svg-text-0033-text-01" descr="{&quot;autofigure_element_id&quot;:&quot;svg-text-0033&quot;}"/>
           <p:cNvSpPr txBox="1"/>
           <p:nvPr/>
         </p:nvSpPr>
@@ -8610,7 +8833,7 @@
         </p:spPr>
         <p:txBody>
           <a:bodyPr wrap="none" anchor="t" lIns="0" rIns="0" tIns="0" bIns="0">
-            <a:spAutoFit/>
+            <a:noAutofit/>
           </a:bodyPr>
           <a:lstStyle/>
           <a:p>
@@ -8629,14 +8852,14 @@
       </p:sp>
       <p:sp>
         <p:nvSpPr>
-          <p:cNvPr id="126" name="af-svg-path-0011-freeform-01"/>
+          <p:cNvPr id="126" name="af-brace-right-early-rationale-under-freeform-01" descr="{&quot;autofigure_element_id&quot;:&quot;brace-right-early-rationale-under&quot;,&quot;brace_spec_sha256&quot;:&quot;6d80d7a4a43033d62f97430451ca3777c54dd3458c17268b41880e17ac8fcc83&quot;,&quot;primitive_spec_sha256&quot;:&quot;6d80d7a4a43033d62f97430451ca3777c54dd3458c17268b41880e17ac8fcc83&quot;}"/>
           <p:cNvSpPr/>
           <p:nvPr/>
         </p:nvSpPr>
         <p:spPr>
           <a:xfrm>
-            <a:off x="10687050" y="2733675"/>
-            <a:ext cx="1076325" cy="123825"/>
+            <a:off x="10715625" y="2743200"/>
+            <a:ext cx="1009650" cy="133350"/>
           </a:xfrm>
           <a:custGeom>
             <a:avLst/>
@@ -8645,57 +8868,73 @@
             <a:cxnLst/>
             <a:rect l="0" t="0" r="0" b="0"/>
             <a:pathLst>
-              <a:path w="1076325" h="123825">
+              <a:path w="1009650" h="133350">
                 <a:moveTo>
                   <a:pt x="0" y="0"/>
                 </a:moveTo>
+                <a:lnTo>
+                  <a:pt x="0" y="38100"/>
+                </a:lnTo>
                 <a:cubicBezTo>
-                  <a:pt x="0" y="66675"/>
+                  <a:pt x="0" y="63500"/>
                   <a:pt x="19050" y="76200"/>
-                  <a:pt x="66675" y="76200"/>
+                  <a:pt x="57150" y="76200"/>
                 </a:cubicBezTo>
                 <a:lnTo>
-                  <a:pt x="447675" y="76200"/>
+                  <a:pt x="457200" y="76200"/>
                 </a:lnTo>
                 <a:cubicBezTo>
-                  <a:pt x="460375" y="107950"/>
-                  <a:pt x="488950" y="123825"/>
-                  <a:pt x="533400" y="123825"/>
-                </a:cubicBezTo>
-                <a:cubicBezTo>
-                  <a:pt x="577850" y="123825"/>
-                  <a:pt x="606425" y="107950"/>
-                  <a:pt x="619125" y="76200"/>
+                  <a:pt x="488950" y="76200"/>
+                  <a:pt x="504825" y="85725"/>
+                  <a:pt x="504825" y="104775"/>
                 </a:cubicBezTo>
                 <a:lnTo>
-                  <a:pt x="1009650" y="76200"/>
+                  <a:pt x="504825" y="133350"/>
+                </a:lnTo>
+                <a:moveTo>
+                  <a:pt x="504825" y="133350"/>
+                </a:moveTo>
+                <a:lnTo>
+                  <a:pt x="504825" y="104775"/>
                 </a:lnTo>
                 <a:cubicBezTo>
-                  <a:pt x="1057275" y="76200"/>
-                  <a:pt x="1076325" y="66675"/>
-                  <a:pt x="1076325" y="0"/>
+                  <a:pt x="504825" y="85725"/>
+                  <a:pt x="520700" y="76200"/>
+                  <a:pt x="552450" y="76200"/>
                 </a:cubicBezTo>
+                <a:lnTo>
+                  <a:pt x="952500" y="76200"/>
+                </a:lnTo>
+                <a:cubicBezTo>
+                  <a:pt x="990600" y="76200"/>
+                  <a:pt x="1009650" y="63500"/>
+                  <a:pt x="1009650" y="38100"/>
+                </a:cubicBezTo>
+                <a:lnTo>
+                  <a:pt x="1009650" y="0"/>
+                </a:lnTo>
               </a:path>
             </a:pathLst>
           </a:custGeom>
           <a:noFill/>
-          <a:ln w="14288">
+          <a:ln w="9525" cap="rnd">
             <a:solidFill>
               <a:srgbClr val="333333"/>
             </a:solidFill>
-          </a:ln>
-        </p:spPr>
-      </p:sp>
-      <p:sp>
-        <p:nvSpPr>
-          <p:cNvPr id="127" name="af-svg-text-0034-text-01"/>
+            <a:miter/>
+          </a:ln>
+        </p:spPr>
+      </p:sp>
+      <p:sp>
+        <p:nvSpPr>
+          <p:cNvPr id="127" name="af-svg-text-0034-text-01" descr="{&quot;autofigure_element_id&quot;:&quot;svg-text-0034&quot;}"/>
           <p:cNvSpPr txBox="1"/>
           <p:nvPr/>
         </p:nvSpPr>
         <p:spPr>
           <a:xfrm rot="16200000">
-            <a:off x="13954125" y="2089547"/>
-            <a:ext cx="457200" cy="392906"/>
+            <a:off x="13954125" y="1885950"/>
+            <a:ext cx="457200" cy="800100"/>
           </a:xfrm>
           <a:prstGeom prst="rect">
             <a:avLst/>
@@ -8705,7 +8944,7 @@
         </p:spPr>
         <p:txBody>
           <a:bodyPr wrap="none" anchor="ctr" lIns="0" rIns="0" tIns="0" bIns="0">
-            <a:spAutoFit/>
+            <a:noAutofit/>
           </a:bodyPr>
           <a:lstStyle/>
           <a:p>
@@ -8724,14 +8963,14 @@
       </p:sp>
       <p:sp>
         <p:nvSpPr>
-          <p:cNvPr id="128" name="af-svg-path-0012-freeform-01"/>
+          <p:cNvPr id="128" name="af-brace-right-early-step-side-freeform-01" descr="{&quot;autofigure_element_id&quot;:&quot;brace-right-early-step-side&quot;,&quot;brace_spec_sha256&quot;:&quot;8ef8f0f660d58bd192880aafda538f76bad8648401fe9c3fb3cf522b10bc4cf2&quot;,&quot;primitive_spec_sha256&quot;:&quot;8ef8f0f660d58bd192880aafda538f76bad8648401fe9c3fb3cf522b10bc4cf2&quot;}"/>
           <p:cNvSpPr/>
           <p:nvPr/>
         </p:nvSpPr>
         <p:spPr>
           <a:xfrm>
-            <a:off x="13906500" y="1952625"/>
-            <a:ext cx="123825" cy="714375"/>
+            <a:off x="13849350" y="1933575"/>
+            <a:ext cx="152400" cy="723900"/>
           </a:xfrm>
           <a:custGeom>
             <a:avLst/>
@@ -8740,57 +8979,73 @@
             <a:cxnLst/>
             <a:rect l="0" t="0" r="0" b="0"/>
             <a:pathLst>
-              <a:path w="123825" h="714375">
+              <a:path w="152400" h="723900">
                 <a:moveTo>
                   <a:pt x="0" y="0"/>
                 </a:moveTo>
+                <a:lnTo>
+                  <a:pt x="38100" y="0"/>
+                </a:lnTo>
                 <a:cubicBezTo>
                   <a:pt x="66675" y="0"/>
-                  <a:pt x="76200" y="19050"/>
-                  <a:pt x="76200" y="66675"/>
+                  <a:pt x="80962" y="19050"/>
+                  <a:pt x="80962" y="57150"/>
                 </a:cubicBezTo>
                 <a:lnTo>
-                  <a:pt x="76200" y="257175"/>
+                  <a:pt x="80962" y="314325"/>
                 </a:lnTo>
                 <a:cubicBezTo>
-                  <a:pt x="107950" y="269875"/>
-                  <a:pt x="123825" y="295275"/>
-                  <a:pt x="123825" y="333375"/>
-                </a:cubicBezTo>
-                <a:cubicBezTo>
-                  <a:pt x="123825" y="371475"/>
-                  <a:pt x="107950" y="396875"/>
-                  <a:pt x="76200" y="409575"/>
+                  <a:pt x="80962" y="346075"/>
+                  <a:pt x="95250" y="361950"/>
+                  <a:pt x="123825" y="361950"/>
                 </a:cubicBezTo>
                 <a:lnTo>
-                  <a:pt x="76200" y="647700"/>
+                  <a:pt x="152400" y="361950"/>
+                </a:lnTo>
+                <a:moveTo>
+                  <a:pt x="152400" y="361950"/>
+                </a:moveTo>
+                <a:lnTo>
+                  <a:pt x="123825" y="361950"/>
                 </a:lnTo>
                 <a:cubicBezTo>
-                  <a:pt x="76200" y="695325"/>
-                  <a:pt x="66675" y="714375"/>
-                  <a:pt x="0" y="714375"/>
+                  <a:pt x="95250" y="361950"/>
+                  <a:pt x="80962" y="377825"/>
+                  <a:pt x="80962" y="409575"/>
                 </a:cubicBezTo>
+                <a:lnTo>
+                  <a:pt x="80962" y="666750"/>
+                </a:lnTo>
+                <a:cubicBezTo>
+                  <a:pt x="80962" y="704850"/>
+                  <a:pt x="66675" y="723900"/>
+                  <a:pt x="38100" y="723900"/>
+                </a:cubicBezTo>
+                <a:lnTo>
+                  <a:pt x="0" y="723900"/>
+                </a:lnTo>
               </a:path>
             </a:pathLst>
           </a:custGeom>
           <a:noFill/>
-          <a:ln w="14288">
+          <a:ln w="9525" cap="rnd">
             <a:solidFill>
               <a:srgbClr val="333333"/>
             </a:solidFill>
-          </a:ln>
-        </p:spPr>
-      </p:sp>
-      <p:sp>
-        <p:nvSpPr>
-          <p:cNvPr id="129" name="af-svg-text-0035-text-01"/>
+            <a:miter/>
+          </a:ln>
+        </p:spPr>
+      </p:sp>
+      <p:sp>
+        <p:nvSpPr>
+          <p:cNvPr id="129" name="af-caption-right-early-line1-text-01" descr="{&quot;autofigure_element_id&quot;:&quot;caption-right-early-line1&quot;}"/>
           <p:cNvSpPr txBox="1"/>
           <p:nvPr/>
         </p:nvSpPr>
         <p:spPr>
           <a:xfrm>
-            <a:off x="10220420" y="2801302"/>
-            <a:ext cx="2000060" cy="452438"/>
+            <a:off x="10321504" y="2804874"/>
+            <a:ext cx="1807416" cy="422672"/>
           </a:xfrm>
           <a:prstGeom prst="rect">
             <a:avLst/>
@@ -8800,13 +9055,13 @@
         </p:spPr>
         <p:txBody>
           <a:bodyPr wrap="none" anchor="t" lIns="0" rIns="0" tIns="0" bIns="0">
-            <a:spAutoFit/>
+            <a:noAutofit/>
           </a:bodyPr>
           <a:lstStyle/>
           <a:p>
             <a:pPr algn="ctr"/>
             <a:r>
-              <a:rPr sz="1650" b="1">
+              <a:rPr sz="1462" b="1">
                 <a:solidFill>
                   <a:srgbClr val="00A651"/>
                 </a:solidFill>
@@ -8819,14 +9074,14 @@
       </p:sp>
       <p:sp>
         <p:nvSpPr>
-          <p:cNvPr id="130" name="af-svg-text-0036-text-01"/>
+          <p:cNvPr id="130" name="af-caption-right-early-line2-text-01" descr="{&quot;autofigure_element_id&quot;:&quot;caption-right-early-line2&quot;}"/>
           <p:cNvSpPr txBox="1"/>
           <p:nvPr/>
         </p:nvSpPr>
         <p:spPr>
           <a:xfrm>
-            <a:off x="10270712" y="3068002"/>
-            <a:ext cx="1899475" cy="452438"/>
+            <a:off x="10366081" y="3033474"/>
+            <a:ext cx="1718262" cy="422672"/>
           </a:xfrm>
           <a:prstGeom prst="rect">
             <a:avLst/>
@@ -8836,13 +9091,13 @@
         </p:spPr>
         <p:txBody>
           <a:bodyPr wrap="none" anchor="t" lIns="0" rIns="0" tIns="0" bIns="0">
-            <a:spAutoFit/>
+            <a:noAutofit/>
           </a:bodyPr>
           <a:lstStyle/>
           <a:p>
             <a:pPr algn="ctr"/>
             <a:r>
-              <a:rPr sz="1650" b="1">
+              <a:rPr sz="1462" b="1">
                 <a:solidFill>
                   <a:srgbClr val="00A651"/>
                 </a:solidFill>
@@ -8855,20 +9110,20 @@
       </p:sp>
       <p:sp>
         <p:nvSpPr>
-          <p:cNvPr id="131" name="af-svg-circle-0019-ellipse-01"/>
+          <p:cNvPr id="131" name="af-ellipsis-right-transition-dot-1-ellipse-01" descr="{&quot;autofigure_element_id&quot;:&quot;ellipsis-right-transition-dot-1&quot;}"/>
           <p:cNvSpPr/>
           <p:nvPr/>
         </p:nvSpPr>
         <p:spPr>
           <a:xfrm>
-            <a:off x="11951970" y="3141345"/>
-            <a:ext cx="41910" cy="41910"/>
+            <a:off x="11982450" y="3086100"/>
+            <a:ext cx="19050" cy="19050"/>
           </a:xfrm>
           <a:prstGeom prst="ellipse">
             <a:avLst/>
           </a:prstGeom>
           <a:solidFill>
-            <a:srgbClr val="666666"/>
+            <a:srgbClr val="000000"/>
           </a:solidFill>
           <a:ln>
             <a:noFill/>
@@ -8899,20 +9154,20 @@
       </p:sp>
       <p:sp>
         <p:nvSpPr>
-          <p:cNvPr id="132" name="af-svg-circle-0020-ellipse-01"/>
+          <p:cNvPr id="132" name="af-ellipsis-right-transition-dot-2-ellipse-01" descr="{&quot;autofigure_element_id&quot;:&quot;ellipsis-right-transition-dot-2&quot;}"/>
           <p:cNvSpPr/>
           <p:nvPr/>
         </p:nvSpPr>
         <p:spPr>
           <a:xfrm>
-            <a:off x="11951970" y="3236595"/>
-            <a:ext cx="41910" cy="41910"/>
+            <a:off x="11982450" y="3152775"/>
+            <a:ext cx="19050" cy="19050"/>
           </a:xfrm>
           <a:prstGeom prst="ellipse">
             <a:avLst/>
           </a:prstGeom>
           <a:solidFill>
-            <a:srgbClr val="666666"/>
+            <a:srgbClr val="000000"/>
           </a:solidFill>
           <a:ln>
             <a:noFill/>
@@ -8943,20 +9198,20 @@
       </p:sp>
       <p:sp>
         <p:nvSpPr>
-          <p:cNvPr id="133" name="af-svg-circle-0021-ellipse-01"/>
+          <p:cNvPr id="133" name="af-ellipsis-right-transition-dot-3-ellipse-01" descr="{&quot;autofigure_element_id&quot;:&quot;ellipsis-right-transition-dot-3&quot;}"/>
           <p:cNvSpPr/>
           <p:nvPr/>
         </p:nvSpPr>
         <p:spPr>
           <a:xfrm>
-            <a:off x="11951970" y="3331845"/>
-            <a:ext cx="41910" cy="41910"/>
+            <a:off x="11982450" y="3219450"/>
+            <a:ext cx="19050" cy="19050"/>
           </a:xfrm>
           <a:prstGeom prst="ellipse">
             <a:avLst/>
           </a:prstGeom>
           <a:solidFill>
-            <a:srgbClr val="666666"/>
+            <a:srgbClr val="000000"/>
           </a:solidFill>
           <a:ln>
             <a:noFill/>
@@ -8987,22 +9242,23 @@
       </p:sp>
       <p:cxnSp>
         <p:nvCxnSpPr>
-          <p:cNvPr id="134" name="af-svg-line-0006-connector-01"/>
+          <p:cNvPr id="134" name="af-arrow-right-to-later-step-connector-01" descr="{&quot;arrow_spec_sha256&quot;:&quot;e7e136ff9f33cc6b22a45e192f198b21761f1ce4933aff86d4e706c0a497217a&quot;,&quot;autofigure_element_id&quot;:&quot;arrow-right-to-later-step&quot;}"/>
           <p:cNvCxnSpPr/>
           <p:nvPr/>
         </p:nvCxnSpPr>
         <p:spPr>
           <a:xfrm>
-            <a:off x="11972925" y="3409950"/>
-            <a:ext cx="0" cy="209550"/>
+            <a:off x="11991975" y="3381375"/>
+            <a:ext cx="0" cy="219075"/>
           </a:xfrm>
           <a:prstGeom prst="line">
             <a:avLst/>
           </a:prstGeom>
           <a:ln w="19050">
             <a:solidFill>
-              <a:srgbClr val="333333"/>
+              <a:srgbClr val="000000"/>
             </a:solidFill>
+            <a:miter/>
             <a:tailEnd type="triangle" w="med" len="med"/>
           </a:ln>
           <a:effectLst/>
@@ -9024,7 +9280,7 @@
       </p:cxnSp>
       <p:sp>
         <p:nvSpPr>
-          <p:cNvPr id="135" name="af-svg-rect-0059-rect-01"/>
+          <p:cNvPr id="135" name="af-svg-rect-0059-rect-01" descr="{&quot;autofigure_element_id&quot;:&quot;svg-rect-0059&quot;}"/>
           <p:cNvSpPr/>
           <p:nvPr/>
         </p:nvSpPr>
@@ -9045,6 +9301,7 @@
             <a:solidFill>
               <a:srgbClr val="1E7FB8"/>
             </a:solidFill>
+            <a:miter/>
           </a:ln>
           <a:effectLst/>
         </p:spPr>
@@ -9072,7 +9329,7 @@
       </p:sp>
       <p:sp>
         <p:nvSpPr>
-          <p:cNvPr id="136" name="af-svg-rect-0060-rect-01"/>
+          <p:cNvPr id="136" name="af-svg-rect-0060-rect-01" descr="{&quot;autofigure_element_id&quot;:&quot;svg-rect-0060&quot;}"/>
           <p:cNvSpPr/>
           <p:nvPr/>
         </p:nvSpPr>
@@ -9093,6 +9350,7 @@
             <a:solidFill>
               <a:srgbClr val="1E7FB8"/>
             </a:solidFill>
+            <a:miter/>
           </a:ln>
           <a:effectLst/>
         </p:spPr>
@@ -9120,7 +9378,7 @@
       </p:sp>
       <p:sp>
         <p:nvSpPr>
-          <p:cNvPr id="137" name="af-svg-rect-0061-rect-01"/>
+          <p:cNvPr id="137" name="af-svg-rect-0061-rect-01" descr="{&quot;autofigure_element_id&quot;:&quot;svg-rect-0061&quot;}"/>
           <p:cNvSpPr/>
           <p:nvPr/>
         </p:nvSpPr>
@@ -9141,6 +9399,7 @@
             <a:solidFill>
               <a:srgbClr val="1E7FB8"/>
             </a:solidFill>
+            <a:miter/>
           </a:ln>
           <a:effectLst/>
         </p:spPr>
@@ -9168,7 +9427,7 @@
       </p:sp>
       <p:sp>
         <p:nvSpPr>
-          <p:cNvPr id="138" name="af-svg-rect-0062-rect-01"/>
+          <p:cNvPr id="138" name="af-svg-rect-0062-rect-01" descr="{&quot;autofigure_element_id&quot;:&quot;svg-rect-0062&quot;}"/>
           <p:cNvSpPr/>
           <p:nvPr/>
         </p:nvSpPr>
@@ -9189,6 +9448,7 @@
             <a:solidFill>
               <a:srgbClr val="1E7FB8"/>
             </a:solidFill>
+            <a:miter/>
           </a:ln>
           <a:effectLst/>
         </p:spPr>
@@ -9216,20 +9476,20 @@
       </p:sp>
       <p:sp>
         <p:nvSpPr>
-          <p:cNvPr id="139" name="af-svg-circle-0022-ellipse-01"/>
+          <p:cNvPr id="139" name="af-ellipsis-right-later-row-dot-1-ellipse-01" descr="{&quot;autofigure_element_id&quot;:&quot;ellipsis-right-later-row-dot-1&quot;}"/>
           <p:cNvSpPr/>
           <p:nvPr/>
         </p:nvSpPr>
         <p:spPr>
           <a:xfrm>
-            <a:off x="11885295" y="3779520"/>
-            <a:ext cx="41910" cy="41910"/>
+            <a:off x="11908631" y="3764756"/>
+            <a:ext cx="23812" cy="23812"/>
           </a:xfrm>
           <a:prstGeom prst="ellipse">
             <a:avLst/>
           </a:prstGeom>
           <a:solidFill>
-            <a:srgbClr val="666666"/>
+            <a:srgbClr val="000000"/>
           </a:solidFill>
           <a:ln>
             <a:noFill/>
@@ -9260,20 +9520,20 @@
       </p:sp>
       <p:sp>
         <p:nvSpPr>
-          <p:cNvPr id="140" name="af-svg-circle-0023-ellipse-01"/>
+          <p:cNvPr id="140" name="af-ellipsis-right-later-row-dot-2-ellipse-01" descr="{&quot;autofigure_element_id&quot;:&quot;ellipsis-right-later-row-dot-2&quot;}"/>
           <p:cNvSpPr/>
           <p:nvPr/>
         </p:nvSpPr>
         <p:spPr>
           <a:xfrm>
-            <a:off x="11961495" y="3779520"/>
-            <a:ext cx="41910" cy="41910"/>
+            <a:off x="11980069" y="3764756"/>
+            <a:ext cx="23812" cy="23812"/>
           </a:xfrm>
           <a:prstGeom prst="ellipse">
             <a:avLst/>
           </a:prstGeom>
           <a:solidFill>
-            <a:srgbClr val="666666"/>
+            <a:srgbClr val="000000"/>
           </a:solidFill>
           <a:ln>
             <a:noFill/>
@@ -9304,20 +9564,20 @@
       </p:sp>
       <p:sp>
         <p:nvSpPr>
-          <p:cNvPr id="141" name="af-svg-circle-0024-ellipse-01"/>
+          <p:cNvPr id="141" name="af-ellipsis-right-later-row-dot-3-ellipse-01" descr="{&quot;autofigure_element_id&quot;:&quot;ellipsis-right-later-row-dot-3&quot;}"/>
           <p:cNvSpPr/>
           <p:nvPr/>
         </p:nvSpPr>
         <p:spPr>
           <a:xfrm>
-            <a:off x="12037695" y="3779520"/>
-            <a:ext cx="41910" cy="41910"/>
+            <a:off x="12046744" y="3764756"/>
+            <a:ext cx="23812" cy="23812"/>
           </a:xfrm>
           <a:prstGeom prst="ellipse">
             <a:avLst/>
           </a:prstGeom>
           <a:solidFill>
-            <a:srgbClr val="666666"/>
+            <a:srgbClr val="000000"/>
           </a:solidFill>
           <a:ln>
             <a:noFill/>
@@ -9348,7 +9608,7 @@
       </p:sp>
       <p:sp>
         <p:nvSpPr>
-          <p:cNvPr id="142" name="af-svg-rect-0063-rect-01"/>
+          <p:cNvPr id="142" name="af-svg-rect-0063-rect-01" descr="{&quot;autofigure_element_id&quot;:&quot;svg-rect-0063&quot;}"/>
           <p:cNvSpPr/>
           <p:nvPr/>
         </p:nvSpPr>
@@ -9369,6 +9629,7 @@
             <a:solidFill>
               <a:srgbClr val="B3B3B3"/>
             </a:solidFill>
+            <a:miter/>
           </a:ln>
           <a:effectLst/>
         </p:spPr>
@@ -9396,7 +9657,7 @@
       </p:sp>
       <p:sp>
         <p:nvSpPr>
-          <p:cNvPr id="143" name="af-svg-rect-0064-rect-01"/>
+          <p:cNvPr id="143" name="af-svg-rect-0064-rect-01" descr="{&quot;autofigure_element_id&quot;:&quot;svg-rect-0064&quot;}"/>
           <p:cNvSpPr/>
           <p:nvPr/>
         </p:nvSpPr>
@@ -9417,6 +9678,7 @@
             <a:solidFill>
               <a:srgbClr val="1E7FB8"/>
             </a:solidFill>
+            <a:miter/>
           </a:ln>
           <a:effectLst/>
         </p:spPr>
@@ -9444,7 +9706,7 @@
       </p:sp>
       <p:sp>
         <p:nvSpPr>
-          <p:cNvPr id="144" name="af-svg-rect-0065-rect-01"/>
+          <p:cNvPr id="144" name="af-svg-rect-0065-rect-01" descr="{&quot;autofigure_element_id&quot;:&quot;svg-rect-0065&quot;}"/>
           <p:cNvSpPr/>
           <p:nvPr/>
         </p:nvSpPr>
@@ -9465,6 +9727,7 @@
             <a:solidFill>
               <a:srgbClr val="B3B3B3"/>
             </a:solidFill>
+            <a:miter/>
           </a:ln>
           <a:effectLst/>
         </p:spPr>
@@ -9492,7 +9755,7 @@
       </p:sp>
       <p:sp>
         <p:nvSpPr>
-          <p:cNvPr id="145" name="af-svg-rect-0066-rect-01"/>
+          <p:cNvPr id="145" name="af-svg-rect-0066-rect-01" descr="{&quot;autofigure_element_id&quot;:&quot;svg-rect-0066&quot;}"/>
           <p:cNvSpPr/>
           <p:nvPr/>
         </p:nvSpPr>
@@ -9513,6 +9776,7 @@
             <a:solidFill>
               <a:srgbClr val="1E7FB8"/>
             </a:solidFill>
+            <a:miter/>
           </a:ln>
           <a:effectLst/>
         </p:spPr>
@@ -9540,7 +9804,7 @@
       </p:sp>
       <p:sp>
         <p:nvSpPr>
-          <p:cNvPr id="146" name="af-svg-text-0037-text-01"/>
+          <p:cNvPr id="146" name="af-svg-text-0037-text-01" descr="{&quot;autofigure_element_id&quot;:&quot;svg-text-0037&quot;}"/>
           <p:cNvSpPr txBox="1"/>
           <p:nvPr/>
         </p:nvSpPr>
@@ -9557,7 +9821,7 @@
         </p:spPr>
         <p:txBody>
           <a:bodyPr wrap="none" anchor="t" lIns="0" rIns="0" tIns="0" bIns="0">
-            <a:spAutoFit/>
+            <a:noAutofit/>
           </a:bodyPr>
           <a:lstStyle/>
           <a:p>
@@ -9576,7 +9840,7 @@
       </p:sp>
       <p:sp>
         <p:nvSpPr>
-          <p:cNvPr id="147" name="af-svg-text-0038-text-01"/>
+          <p:cNvPr id="147" name="af-svg-text-0038-text-01" descr="{&quot;autofigure_element_id&quot;:&quot;svg-text-0038&quot;}"/>
           <p:cNvSpPr txBox="1"/>
           <p:nvPr/>
         </p:nvSpPr>
@@ -9593,7 +9857,7 @@
         </p:spPr>
         <p:txBody>
           <a:bodyPr wrap="none" anchor="t" lIns="0" rIns="0" tIns="0" bIns="0">
-            <a:spAutoFit/>
+            <a:noAutofit/>
           </a:bodyPr>
           <a:lstStyle/>
           <a:p>
@@ -9612,7 +9876,7 @@
       </p:sp>
       <p:sp>
         <p:nvSpPr>
-          <p:cNvPr id="148" name="af-svg-text-0039-text-01"/>
+          <p:cNvPr id="148" name="af-svg-text-0039-text-01" descr="{&quot;autofigure_element_id&quot;:&quot;svg-text-0039&quot;}"/>
           <p:cNvSpPr txBox="1"/>
           <p:nvPr/>
         </p:nvSpPr>
@@ -9629,7 +9893,7 @@
         </p:spPr>
         <p:txBody>
           <a:bodyPr wrap="none" anchor="t" lIns="0" rIns="0" tIns="0" bIns="0">
-            <a:spAutoFit/>
+            <a:noAutofit/>
           </a:bodyPr>
           <a:lstStyle/>
           <a:p>
@@ -9648,7 +9912,7 @@
       </p:sp>
       <p:sp>
         <p:nvSpPr>
-          <p:cNvPr id="149" name="af-svg-text-0040-text-01"/>
+          <p:cNvPr id="149" name="af-svg-text-0040-text-01" descr="{&quot;autofigure_element_id&quot;:&quot;svg-text-0040&quot;}"/>
           <p:cNvSpPr txBox="1"/>
           <p:nvPr/>
         </p:nvSpPr>
@@ -9665,7 +9929,7 @@
         </p:spPr>
         <p:txBody>
           <a:bodyPr wrap="none" anchor="t" lIns="0" rIns="0" tIns="0" bIns="0">
-            <a:spAutoFit/>
+            <a:noAutofit/>
           </a:bodyPr>
           <a:lstStyle/>
           <a:p>
@@ -9684,7 +9948,7 @@
       </p:sp>
       <p:sp>
         <p:nvSpPr>
-          <p:cNvPr id="150" name="af-svg-text-0041-text-01"/>
+          <p:cNvPr id="150" name="af-svg-text-0041-text-01" descr="{&quot;autofigure_element_id&quot;:&quot;svg-text-0041&quot;}"/>
           <p:cNvSpPr txBox="1"/>
           <p:nvPr/>
         </p:nvSpPr>
@@ -9701,7 +9965,7 @@
         </p:spPr>
         <p:txBody>
           <a:bodyPr wrap="none" anchor="t" lIns="0" rIns="0" tIns="0" bIns="0">
-            <a:spAutoFit/>
+            <a:noAutofit/>
           </a:bodyPr>
           <a:lstStyle/>
           <a:p>
@@ -9720,7 +9984,7 @@
       </p:sp>
       <p:sp>
         <p:nvSpPr>
-          <p:cNvPr id="151" name="af-svg-text-0042-text-01"/>
+          <p:cNvPr id="151" name="af-svg-text-0042-text-01" descr="{&quot;autofigure_element_id&quot;:&quot;svg-text-0042&quot;}"/>
           <p:cNvSpPr txBox="1"/>
           <p:nvPr/>
         </p:nvSpPr>
@@ -9737,7 +10001,7 @@
         </p:spPr>
         <p:txBody>
           <a:bodyPr wrap="none" anchor="t" lIns="0" rIns="0" tIns="0" bIns="0">
-            <a:spAutoFit/>
+            <a:noAutofit/>
           </a:bodyPr>
           <a:lstStyle/>
           <a:p>
@@ -9756,14 +10020,14 @@
       </p:sp>
       <p:sp>
         <p:nvSpPr>
-          <p:cNvPr id="152" name="af-svg-path-0013-freeform-01"/>
+          <p:cNvPr id="152" name="af-brace-right-later-answer-under-freeform-01" descr="{&quot;autofigure_element_id&quot;:&quot;brace-right-later-answer-under&quot;,&quot;brace_spec_sha256&quot;:&quot;db8718cf72118dde450fa69999c47678410d2876a5df39cf53f9cf3a9fe5a07b&quot;,&quot;primitive_spec_sha256&quot;:&quot;db8718cf72118dde450fa69999c47678410d2876a5df39cf53f9cf3a9fe5a07b&quot;}"/>
           <p:cNvSpPr/>
           <p:nvPr/>
         </p:nvSpPr>
         <p:spPr>
           <a:xfrm>
-            <a:off x="12639675" y="4210050"/>
-            <a:ext cx="1076325" cy="123825"/>
+            <a:off x="12658725" y="4200525"/>
+            <a:ext cx="1009650" cy="152400"/>
           </a:xfrm>
           <a:custGeom>
             <a:avLst/>
@@ -9772,57 +10036,73 @@
             <a:cxnLst/>
             <a:rect l="0" t="0" r="0" b="0"/>
             <a:pathLst>
-              <a:path w="1076325" h="123825">
+              <a:path w="1009650" h="152400">
                 <a:moveTo>
                   <a:pt x="0" y="0"/>
                 </a:moveTo>
+                <a:lnTo>
+                  <a:pt x="0" y="38100"/>
+                </a:lnTo>
                 <a:cubicBezTo>
                   <a:pt x="0" y="66675"/>
-                  <a:pt x="19050" y="76200"/>
-                  <a:pt x="66675" y="76200"/>
+                  <a:pt x="19050" y="80962"/>
+                  <a:pt x="57150" y="80962"/>
                 </a:cubicBezTo>
                 <a:lnTo>
-                  <a:pt x="447675" y="76200"/>
+                  <a:pt x="457200" y="80962"/>
                 </a:lnTo>
                 <a:cubicBezTo>
-                  <a:pt x="460375" y="107950"/>
-                  <a:pt x="488950" y="123825"/>
-                  <a:pt x="533400" y="123825"/>
-                </a:cubicBezTo>
-                <a:cubicBezTo>
-                  <a:pt x="577850" y="123825"/>
-                  <a:pt x="606425" y="107950"/>
-                  <a:pt x="619125" y="76200"/>
+                  <a:pt x="488950" y="80962"/>
+                  <a:pt x="504825" y="95250"/>
+                  <a:pt x="504825" y="123825"/>
                 </a:cubicBezTo>
                 <a:lnTo>
-                  <a:pt x="1009650" y="76200"/>
+                  <a:pt x="504825" y="152400"/>
+                </a:lnTo>
+                <a:moveTo>
+                  <a:pt x="504825" y="152400"/>
+                </a:moveTo>
+                <a:lnTo>
+                  <a:pt x="504825" y="123825"/>
                 </a:lnTo>
                 <a:cubicBezTo>
-                  <a:pt x="1057275" y="76200"/>
-                  <a:pt x="1076325" y="66675"/>
-                  <a:pt x="1076325" y="0"/>
+                  <a:pt x="504825" y="95250"/>
+                  <a:pt x="520700" y="80962"/>
+                  <a:pt x="552450" y="80962"/>
                 </a:cubicBezTo>
+                <a:lnTo>
+                  <a:pt x="952500" y="80962"/>
+                </a:lnTo>
+                <a:cubicBezTo>
+                  <a:pt x="990600" y="80962"/>
+                  <a:pt x="1009650" y="66675"/>
+                  <a:pt x="1009650" y="38100"/>
+                </a:cubicBezTo>
+                <a:lnTo>
+                  <a:pt x="1009650" y="0"/>
+                </a:lnTo>
               </a:path>
             </a:pathLst>
           </a:custGeom>
           <a:noFill/>
-          <a:ln w="14288">
+          <a:ln w="9525" cap="rnd">
             <a:solidFill>
               <a:srgbClr val="333333"/>
             </a:solidFill>
-          </a:ln>
-        </p:spPr>
-      </p:sp>
-      <p:sp>
-        <p:nvSpPr>
-          <p:cNvPr id="153" name="af-svg-text-0043-text-01"/>
+            <a:miter/>
+          </a:ln>
+        </p:spPr>
+      </p:sp>
+      <p:sp>
+        <p:nvSpPr>
+          <p:cNvPr id="153" name="af-svg-text-0043-text-01" descr="{&quot;autofigure_element_id&quot;:&quot;svg-text-0043&quot;}"/>
           <p:cNvSpPr txBox="1"/>
           <p:nvPr/>
         </p:nvSpPr>
         <p:spPr>
           <a:xfrm rot="16200000">
-            <a:off x="13954125" y="3594497"/>
-            <a:ext cx="457200" cy="392906"/>
+            <a:off x="13954125" y="3390900"/>
+            <a:ext cx="457200" cy="800100"/>
           </a:xfrm>
           <a:prstGeom prst="rect">
             <a:avLst/>
@@ -9832,7 +10112,7 @@
         </p:spPr>
         <p:txBody>
           <a:bodyPr wrap="none" anchor="ctr" lIns="0" rIns="0" tIns="0" bIns="0">
-            <a:spAutoFit/>
+            <a:noAutofit/>
           </a:bodyPr>
           <a:lstStyle/>
           <a:p>
@@ -9851,14 +10131,14 @@
       </p:sp>
       <p:sp>
         <p:nvSpPr>
-          <p:cNvPr id="154" name="af-svg-path-0014-freeform-01"/>
+          <p:cNvPr id="154" name="af-brace-right-later-step-side-freeform-01" descr="{&quot;autofigure_element_id&quot;:&quot;brace-right-later-step-side&quot;,&quot;brace_spec_sha256&quot;:&quot;a6a9feb9035eca3e29aa7a6760d0eb19939466fd08a181b26ffb1e1834ffaa87&quot;,&quot;primitive_spec_sha256&quot;:&quot;a6a9feb9035eca3e29aa7a6760d0eb19939466fd08a181b26ffb1e1834ffaa87&quot;}"/>
           <p:cNvSpPr/>
           <p:nvPr/>
         </p:nvSpPr>
         <p:spPr>
           <a:xfrm>
-            <a:off x="13906500" y="3457575"/>
-            <a:ext cx="123825" cy="714375"/>
+            <a:off x="13849350" y="3409950"/>
+            <a:ext cx="142875" cy="723900"/>
           </a:xfrm>
           <a:custGeom>
             <a:avLst/>
@@ -9867,57 +10147,73 @@
             <a:cxnLst/>
             <a:rect l="0" t="0" r="0" b="0"/>
             <a:pathLst>
-              <a:path w="123825" h="714375">
+              <a:path w="142875" h="723900">
                 <a:moveTo>
                   <a:pt x="0" y="0"/>
                 </a:moveTo>
+                <a:lnTo>
+                  <a:pt x="38100" y="0"/>
+                </a:lnTo>
                 <a:cubicBezTo>
                   <a:pt x="66675" y="0"/>
-                  <a:pt x="76200" y="19050"/>
-                  <a:pt x="76200" y="66675"/>
+                  <a:pt x="80962" y="19050"/>
+                  <a:pt x="80962" y="57150"/>
                 </a:cubicBezTo>
                 <a:lnTo>
-                  <a:pt x="76200" y="257175"/>
+                  <a:pt x="80962" y="314325"/>
                 </a:lnTo>
                 <a:cubicBezTo>
-                  <a:pt x="107950" y="269875"/>
-                  <a:pt x="123825" y="295275"/>
-                  <a:pt x="123825" y="333375"/>
-                </a:cubicBezTo>
-                <a:cubicBezTo>
-                  <a:pt x="123825" y="371475"/>
-                  <a:pt x="107950" y="396875"/>
-                  <a:pt x="76200" y="409575"/>
+                  <a:pt x="80962" y="346075"/>
+                  <a:pt x="92075" y="361950"/>
+                  <a:pt x="114300" y="361950"/>
                 </a:cubicBezTo>
                 <a:lnTo>
-                  <a:pt x="76200" y="647700"/>
+                  <a:pt x="142875" y="361950"/>
+                </a:lnTo>
+                <a:moveTo>
+                  <a:pt x="142875" y="361950"/>
+                </a:moveTo>
+                <a:lnTo>
+                  <a:pt x="114300" y="361950"/>
                 </a:lnTo>
                 <a:cubicBezTo>
-                  <a:pt x="76200" y="695325"/>
-                  <a:pt x="66675" y="714375"/>
-                  <a:pt x="0" y="714375"/>
+                  <a:pt x="92075" y="361950"/>
+                  <a:pt x="80962" y="377825"/>
+                  <a:pt x="80962" y="409575"/>
                 </a:cubicBezTo>
+                <a:lnTo>
+                  <a:pt x="80962" y="666750"/>
+                </a:lnTo>
+                <a:cubicBezTo>
+                  <a:pt x="80962" y="704850"/>
+                  <a:pt x="66675" y="723900"/>
+                  <a:pt x="38100" y="723900"/>
+                </a:cubicBezTo>
+                <a:lnTo>
+                  <a:pt x="0" y="723900"/>
+                </a:lnTo>
               </a:path>
             </a:pathLst>
           </a:custGeom>
           <a:noFill/>
-          <a:ln w="14288">
+          <a:ln w="9525" cap="rnd">
             <a:solidFill>
               <a:srgbClr val="333333"/>
             </a:solidFill>
-          </a:ln>
-        </p:spPr>
-      </p:sp>
-      <p:sp>
-        <p:nvSpPr>
-          <p:cNvPr id="155" name="af-svg-text-0044-text-01"/>
+            <a:miter/>
+          </a:ln>
+        </p:spPr>
+      </p:sp>
+      <p:sp>
+        <p:nvSpPr>
+          <p:cNvPr id="155" name="af-caption-right-later-line1-text-01" descr="{&quot;autofigure_element_id&quot;:&quot;caption-right-later-line1&quot;}"/>
           <p:cNvSpPr txBox="1"/>
           <p:nvPr/>
         </p:nvSpPr>
         <p:spPr>
           <a:xfrm>
-            <a:off x="12227433" y="4325302"/>
-            <a:ext cx="1872234" cy="452438"/>
+            <a:off x="12311729" y="4319349"/>
+            <a:ext cx="1694116" cy="422672"/>
           </a:xfrm>
           <a:prstGeom prst="rect">
             <a:avLst/>
@@ -9927,13 +10223,13 @@
         </p:spPr>
         <p:txBody>
           <a:bodyPr wrap="none" anchor="t" lIns="0" rIns="0" tIns="0" bIns="0">
-            <a:spAutoFit/>
+            <a:noAutofit/>
           </a:bodyPr>
           <a:lstStyle/>
           <a:p>
             <a:pPr algn="ctr"/>
             <a:r>
-              <a:rPr sz="1650" b="1">
+              <a:rPr sz="1462" b="1">
                 <a:solidFill>
                   <a:srgbClr val="00A651"/>
                 </a:solidFill>
@@ -9946,14 +10242,14 @@
       </p:sp>
       <p:sp>
         <p:nvSpPr>
-          <p:cNvPr id="156" name="af-svg-text-0045-text-01"/>
+          <p:cNvPr id="156" name="af-caption-right-later-line2-text-01" descr="{&quot;autofigure_element_id&quot;:&quot;caption-right-later-line2&quot;}"/>
           <p:cNvSpPr txBox="1"/>
           <p:nvPr/>
         </p:nvSpPr>
         <p:spPr>
           <a:xfrm>
-            <a:off x="12317540" y="4592002"/>
-            <a:ext cx="1692021" cy="452438"/>
+            <a:off x="12391596" y="4547949"/>
+            <a:ext cx="1534382" cy="422672"/>
           </a:xfrm>
           <a:prstGeom prst="rect">
             <a:avLst/>
@@ -9963,13 +10259,13 @@
         </p:spPr>
         <p:txBody>
           <a:bodyPr wrap="none" anchor="t" lIns="0" rIns="0" tIns="0" bIns="0">
-            <a:spAutoFit/>
+            <a:noAutofit/>
           </a:bodyPr>
           <a:lstStyle/>
           <a:p>
             <a:pPr algn="ctr"/>
             <a:r>
-              <a:rPr sz="1650" b="1">
+              <a:rPr sz="1462" b="1">
                 <a:solidFill>
                   <a:srgbClr val="00A651"/>
                 </a:solidFill>
@@ -9982,7 +10278,7 @@
       </p:sp>
       <p:sp>
         <p:nvSpPr>
-          <p:cNvPr id="157" name="af-svg-text-0046-text-01"/>
+          <p:cNvPr id="157" name="af-svg-text-0046-text-01" descr="{&quot;autofigure_element_id&quot;:&quot;svg-text-0046&quot;}"/>
           <p:cNvSpPr txBox="1"/>
           <p:nvPr/>
         </p:nvSpPr>
@@ -9999,7 +10295,7 @@
         </p:spPr>
         <p:txBody>
           <a:bodyPr wrap="none" anchor="t" lIns="0" rIns="0" tIns="0" bIns="0">
-            <a:spAutoFit/>
+            <a:noAutofit/>
           </a:bodyPr>
           <a:lstStyle/>
           <a:p>

</xml_diff>